<commit_message>
docs(session-18): manuelle PPTX-Edits als authoritative Fassung
Die lokale Version (54 KB) enthaelt manuelle Bearbeitungen gegenueber
dem Generator-Output (48 KB, Stand Session 15). Entscheidung (2026-04-16):
manuelle Edits werden als Wahrheit festgeschrieben; kuenftige
Generator-Laeufe muessten die Aenderungen reintegrieren, bevor sie die
Datei ueberschreiben.

Co-Authored-By: Claude Opus 4.7 (1M context) <noreply@anthropic.com>
</commit_message>
<xml_diff>
--- a/docs/silvio-derivatives/goldoni-retail-ueberblick.pptx
+++ b/docs/silvio-derivatives/goldoni-retail-ueberblick.pptx
@@ -5,20 +5,20 @@
     <p:sldMasterId id="2147483648" r:id="rId1"/>
   </p:sldMasterIdLst>
   <p:sldIdLst>
-    <p:sldId id="256" r:id="rId7"/>
-    <p:sldId id="257" r:id="rId8"/>
-    <p:sldId id="258" r:id="rId9"/>
-    <p:sldId id="259" r:id="rId10"/>
-    <p:sldId id="260" r:id="rId11"/>
-    <p:sldId id="261" r:id="rId12"/>
-    <p:sldId id="262" r:id="rId13"/>
-    <p:sldId id="263" r:id="rId14"/>
-    <p:sldId id="264" r:id="rId15"/>
-    <p:sldId id="265" r:id="rId16"/>
-    <p:sldId id="266" r:id="rId17"/>
-    <p:sldId id="267" r:id="rId18"/>
+    <p:sldId id="256" r:id="rId2"/>
+    <p:sldId id="257" r:id="rId3"/>
+    <p:sldId id="258" r:id="rId4"/>
+    <p:sldId id="259" r:id="rId5"/>
+    <p:sldId id="260" r:id="rId6"/>
+    <p:sldId id="261" r:id="rId7"/>
+    <p:sldId id="262" r:id="rId8"/>
+    <p:sldId id="263" r:id="rId9"/>
+    <p:sldId id="264" r:id="rId10"/>
+    <p:sldId id="265" r:id="rId11"/>
+    <p:sldId id="266" r:id="rId12"/>
+    <p:sldId id="267" r:id="rId13"/>
   </p:sldIdLst>
-  <p:sldSz cx="12191695" cy="6858000" type="screen4x3"/>
+  <p:sldSz cx="12192000" cy="6858000"/>
   <p:notesSz cx="6858000" cy="9144000"/>
   <p:defaultTextStyle>
     <a:defPPr>
@@ -115,6 +115,22 @@
       </a:defRPr>
     </a:lvl9pPr>
   </p:defaultTextStyle>
+  <p:extLst>
+    <p:ext uri="{EFAFB233-063F-42B5-8137-9DF3F51BA10A}">
+      <p15:sldGuideLst xmlns:p15="http://schemas.microsoft.com/office/powerpoint/2012/main">
+        <p15:guide id="1" orient="horz" pos="2160">
+          <p15:clr>
+            <a:srgbClr val="A4A3A4"/>
+          </p15:clr>
+        </p15:guide>
+        <p15:guide id="2" pos="2880">
+          <p15:clr>
+            <a:srgbClr val="A4A3A4"/>
+          </p15:clr>
+        </p15:guide>
+      </p15:sldGuideLst>
+    </p:ext>
+  </p:extLst>
 </p:presentation>
 </file>
 
@@ -156,10 +172,9 @@
           <a:lstStyle/>
           <a:p>
             <a:r>
-              <a:rPr lang="en-US" smtClean="0"/>
+              <a:rPr lang="en-US"/>
               <a:t>Click to edit Master title style</a:t>
             </a:r>
-            <a:endParaRPr lang="en-US"/>
           </a:p>
         </p:txBody>
       </p:sp>
@@ -275,10 +290,9 @@
           </a:lstStyle>
           <a:p>
             <a:r>
-              <a:rPr lang="en-US" smtClean="0"/>
+              <a:rPr lang="en-US"/>
               <a:t>Click to edit Master subtitle style</a:t>
             </a:r>
-            <a:endParaRPr lang="en-US"/>
           </a:p>
         </p:txBody>
       </p:sp>
@@ -299,7 +313,7 @@
           <a:p>
             <a:fld id="{5BCAD085-E8A6-8845-BD4E-CB4CCA059FC4}" type="datetimeFigureOut">
               <a:rPr lang="en-US" smtClean="0"/>
-              <a:t>1/27/13</a:t>
+              <a:t>4/13/26</a:t>
             </a:fld>
             <a:endParaRPr lang="en-US"/>
           </a:p>
@@ -341,7 +355,7 @@
           <a:p>
             <a:fld id="{C1FF6DA9-008F-8B48-92A6-B652298478BF}" type="slidenum">
               <a:rPr lang="en-US" smtClean="0"/>
-              <a:t>‹#›</a:t>
+              <a:t>‹Nr.›</a:t>
             </a:fld>
             <a:endParaRPr lang="en-US"/>
           </a:p>
@@ -393,10 +407,9 @@
           <a:lstStyle/>
           <a:p>
             <a:r>
-              <a:rPr lang="en-US" smtClean="0"/>
+              <a:rPr lang="en-US"/>
               <a:t>Click to edit Master title style</a:t>
             </a:r>
-            <a:endParaRPr lang="en-US"/>
           </a:p>
         </p:txBody>
       </p:sp>
@@ -417,38 +430,37 @@
           <a:p>
             <a:pPr lvl="0"/>
             <a:r>
-              <a:rPr lang="en-US" smtClean="0"/>
+              <a:rPr lang="en-US"/>
               <a:t>Click to edit Master text styles</a:t>
             </a:r>
           </a:p>
           <a:p>
             <a:pPr lvl="1"/>
             <a:r>
-              <a:rPr lang="en-US" smtClean="0"/>
+              <a:rPr lang="en-US"/>
               <a:t>Second level</a:t>
             </a:r>
           </a:p>
           <a:p>
             <a:pPr lvl="2"/>
             <a:r>
-              <a:rPr lang="en-US" smtClean="0"/>
+              <a:rPr lang="en-US"/>
               <a:t>Third level</a:t>
             </a:r>
           </a:p>
           <a:p>
             <a:pPr lvl="3"/>
             <a:r>
-              <a:rPr lang="en-US" smtClean="0"/>
+              <a:rPr lang="en-US"/>
               <a:t>Fourth level</a:t>
             </a:r>
           </a:p>
           <a:p>
             <a:pPr lvl="4"/>
             <a:r>
-              <a:rPr lang="en-US" smtClean="0"/>
+              <a:rPr lang="en-US"/>
               <a:t>Fifth level</a:t>
             </a:r>
-            <a:endParaRPr lang="en-US"/>
           </a:p>
         </p:txBody>
       </p:sp>
@@ -469,7 +481,7 @@
           <a:p>
             <a:fld id="{5BCAD085-E8A6-8845-BD4E-CB4CCA059FC4}" type="datetimeFigureOut">
               <a:rPr lang="en-US" smtClean="0"/>
-              <a:t>1/27/13</a:t>
+              <a:t>4/13/26</a:t>
             </a:fld>
             <a:endParaRPr lang="en-US"/>
           </a:p>
@@ -511,7 +523,7 @@
           <a:p>
             <a:fld id="{C1FF6DA9-008F-8B48-92A6-B652298478BF}" type="slidenum">
               <a:rPr lang="en-US" smtClean="0"/>
-              <a:t>‹#›</a:t>
+              <a:t>‹Nr.›</a:t>
             </a:fld>
             <a:endParaRPr lang="en-US"/>
           </a:p>
@@ -568,10 +580,9 @@
           <a:lstStyle/>
           <a:p>
             <a:r>
-              <a:rPr lang="en-US" smtClean="0"/>
+              <a:rPr lang="en-US"/>
               <a:t>Click to edit Master title style</a:t>
             </a:r>
-            <a:endParaRPr lang="en-US"/>
           </a:p>
         </p:txBody>
       </p:sp>
@@ -597,38 +608,37 @@
           <a:p>
             <a:pPr lvl="0"/>
             <a:r>
-              <a:rPr lang="en-US" smtClean="0"/>
+              <a:rPr lang="en-US"/>
               <a:t>Click to edit Master text styles</a:t>
             </a:r>
           </a:p>
           <a:p>
             <a:pPr lvl="1"/>
             <a:r>
-              <a:rPr lang="en-US" smtClean="0"/>
+              <a:rPr lang="en-US"/>
               <a:t>Second level</a:t>
             </a:r>
           </a:p>
           <a:p>
             <a:pPr lvl="2"/>
             <a:r>
-              <a:rPr lang="en-US" smtClean="0"/>
+              <a:rPr lang="en-US"/>
               <a:t>Third level</a:t>
             </a:r>
           </a:p>
           <a:p>
             <a:pPr lvl="3"/>
             <a:r>
-              <a:rPr lang="en-US" smtClean="0"/>
+              <a:rPr lang="en-US"/>
               <a:t>Fourth level</a:t>
             </a:r>
           </a:p>
           <a:p>
             <a:pPr lvl="4"/>
             <a:r>
-              <a:rPr lang="en-US" smtClean="0"/>
+              <a:rPr lang="en-US"/>
               <a:t>Fifth level</a:t>
             </a:r>
-            <a:endParaRPr lang="en-US"/>
           </a:p>
         </p:txBody>
       </p:sp>
@@ -649,7 +659,7 @@
           <a:p>
             <a:fld id="{5BCAD085-E8A6-8845-BD4E-CB4CCA059FC4}" type="datetimeFigureOut">
               <a:rPr lang="en-US" smtClean="0"/>
-              <a:t>1/27/13</a:t>
+              <a:t>4/13/26</a:t>
             </a:fld>
             <a:endParaRPr lang="en-US"/>
           </a:p>
@@ -691,7 +701,7 @@
           <a:p>
             <a:fld id="{C1FF6DA9-008F-8B48-92A6-B652298478BF}" type="slidenum">
               <a:rPr lang="en-US" smtClean="0"/>
-              <a:t>‹#›</a:t>
+              <a:t>‹Nr.›</a:t>
             </a:fld>
             <a:endParaRPr lang="en-US"/>
           </a:p>
@@ -743,10 +753,9 @@
           <a:lstStyle/>
           <a:p>
             <a:r>
-              <a:rPr lang="en-US" smtClean="0"/>
+              <a:rPr lang="en-US"/>
               <a:t>Click to edit Master title style</a:t>
             </a:r>
-            <a:endParaRPr lang="en-US"/>
           </a:p>
         </p:txBody>
       </p:sp>
@@ -767,38 +776,37 @@
           <a:p>
             <a:pPr lvl="0"/>
             <a:r>
-              <a:rPr lang="en-US" smtClean="0"/>
+              <a:rPr lang="en-US"/>
               <a:t>Click to edit Master text styles</a:t>
             </a:r>
           </a:p>
           <a:p>
             <a:pPr lvl="1"/>
             <a:r>
-              <a:rPr lang="en-US" smtClean="0"/>
+              <a:rPr lang="en-US"/>
               <a:t>Second level</a:t>
             </a:r>
           </a:p>
           <a:p>
             <a:pPr lvl="2"/>
             <a:r>
-              <a:rPr lang="en-US" smtClean="0"/>
+              <a:rPr lang="en-US"/>
               <a:t>Third level</a:t>
             </a:r>
           </a:p>
           <a:p>
             <a:pPr lvl="3"/>
             <a:r>
-              <a:rPr lang="en-US" smtClean="0"/>
+              <a:rPr lang="en-US"/>
               <a:t>Fourth level</a:t>
             </a:r>
           </a:p>
           <a:p>
             <a:pPr lvl="4"/>
             <a:r>
-              <a:rPr lang="en-US" smtClean="0"/>
+              <a:rPr lang="en-US"/>
               <a:t>Fifth level</a:t>
             </a:r>
-            <a:endParaRPr lang="en-US"/>
           </a:p>
         </p:txBody>
       </p:sp>
@@ -819,7 +827,7 @@
           <a:p>
             <a:fld id="{5BCAD085-E8A6-8845-BD4E-CB4CCA059FC4}" type="datetimeFigureOut">
               <a:rPr lang="en-US" smtClean="0"/>
-              <a:t>1/27/13</a:t>
+              <a:t>4/13/26</a:t>
             </a:fld>
             <a:endParaRPr lang="en-US"/>
           </a:p>
@@ -861,7 +869,7 @@
           <a:p>
             <a:fld id="{C1FF6DA9-008F-8B48-92A6-B652298478BF}" type="slidenum">
               <a:rPr lang="en-US" smtClean="0"/>
-              <a:t>‹#›</a:t>
+              <a:t>‹Nr.›</a:t>
             </a:fld>
             <a:endParaRPr lang="en-US"/>
           </a:p>
@@ -922,10 +930,9 @@
           </a:lstStyle>
           <a:p>
             <a:r>
-              <a:rPr lang="en-US" smtClean="0"/>
+              <a:rPr lang="en-US"/>
               <a:t>Click to edit Master title style</a:t>
             </a:r>
-            <a:endParaRPr lang="en-US"/>
           </a:p>
         </p:txBody>
       </p:sp>
@@ -1042,7 +1049,7 @@
           <a:p>
             <a:pPr lvl="0"/>
             <a:r>
-              <a:rPr lang="en-US" smtClean="0"/>
+              <a:rPr lang="en-US"/>
               <a:t>Click to edit Master text styles</a:t>
             </a:r>
           </a:p>
@@ -1065,7 +1072,7 @@
           <a:p>
             <a:fld id="{5BCAD085-E8A6-8845-BD4E-CB4CCA059FC4}" type="datetimeFigureOut">
               <a:rPr lang="en-US" smtClean="0"/>
-              <a:t>1/27/13</a:t>
+              <a:t>4/13/26</a:t>
             </a:fld>
             <a:endParaRPr lang="en-US"/>
           </a:p>
@@ -1107,7 +1114,7 @@
           <a:p>
             <a:fld id="{C1FF6DA9-008F-8B48-92A6-B652298478BF}" type="slidenum">
               <a:rPr lang="en-US" smtClean="0"/>
-              <a:t>‹#›</a:t>
+              <a:t>‹Nr.›</a:t>
             </a:fld>
             <a:endParaRPr lang="en-US"/>
           </a:p>
@@ -1159,10 +1166,9 @@
           <a:lstStyle/>
           <a:p>
             <a:r>
-              <a:rPr lang="en-US" smtClean="0"/>
+              <a:rPr lang="en-US"/>
               <a:t>Click to edit Master title style</a:t>
             </a:r>
-            <a:endParaRPr lang="en-US"/>
           </a:p>
         </p:txBody>
       </p:sp>
@@ -1216,38 +1222,37 @@
           <a:p>
             <a:pPr lvl="0"/>
             <a:r>
-              <a:rPr lang="en-US" smtClean="0"/>
+              <a:rPr lang="en-US"/>
               <a:t>Click to edit Master text styles</a:t>
             </a:r>
           </a:p>
           <a:p>
             <a:pPr lvl="1"/>
             <a:r>
-              <a:rPr lang="en-US" smtClean="0"/>
+              <a:rPr lang="en-US"/>
               <a:t>Second level</a:t>
             </a:r>
           </a:p>
           <a:p>
             <a:pPr lvl="2"/>
             <a:r>
-              <a:rPr lang="en-US" smtClean="0"/>
+              <a:rPr lang="en-US"/>
               <a:t>Third level</a:t>
             </a:r>
           </a:p>
           <a:p>
             <a:pPr lvl="3"/>
             <a:r>
-              <a:rPr lang="en-US" smtClean="0"/>
+              <a:rPr lang="en-US"/>
               <a:t>Fourth level</a:t>
             </a:r>
           </a:p>
           <a:p>
             <a:pPr lvl="4"/>
             <a:r>
-              <a:rPr lang="en-US" smtClean="0"/>
+              <a:rPr lang="en-US"/>
               <a:t>Fifth level</a:t>
             </a:r>
-            <a:endParaRPr lang="en-US"/>
           </a:p>
         </p:txBody>
       </p:sp>
@@ -1301,38 +1306,37 @@
           <a:p>
             <a:pPr lvl="0"/>
             <a:r>
-              <a:rPr lang="en-US" smtClean="0"/>
+              <a:rPr lang="en-US"/>
               <a:t>Click to edit Master text styles</a:t>
             </a:r>
           </a:p>
           <a:p>
             <a:pPr lvl="1"/>
             <a:r>
-              <a:rPr lang="en-US" smtClean="0"/>
+              <a:rPr lang="en-US"/>
               <a:t>Second level</a:t>
             </a:r>
           </a:p>
           <a:p>
             <a:pPr lvl="2"/>
             <a:r>
-              <a:rPr lang="en-US" smtClean="0"/>
+              <a:rPr lang="en-US"/>
               <a:t>Third level</a:t>
             </a:r>
           </a:p>
           <a:p>
             <a:pPr lvl="3"/>
             <a:r>
-              <a:rPr lang="en-US" smtClean="0"/>
+              <a:rPr lang="en-US"/>
               <a:t>Fourth level</a:t>
             </a:r>
           </a:p>
           <a:p>
             <a:pPr lvl="4"/>
             <a:r>
-              <a:rPr lang="en-US" smtClean="0"/>
+              <a:rPr lang="en-US"/>
               <a:t>Fifth level</a:t>
             </a:r>
-            <a:endParaRPr lang="en-US"/>
           </a:p>
         </p:txBody>
       </p:sp>
@@ -1353,7 +1357,7 @@
           <a:p>
             <a:fld id="{5BCAD085-E8A6-8845-BD4E-CB4CCA059FC4}" type="datetimeFigureOut">
               <a:rPr lang="en-US" smtClean="0"/>
-              <a:t>1/27/13</a:t>
+              <a:t>4/13/26</a:t>
             </a:fld>
             <a:endParaRPr lang="en-US"/>
           </a:p>
@@ -1395,7 +1399,7 @@
           <a:p>
             <a:fld id="{C1FF6DA9-008F-8B48-92A6-B652298478BF}" type="slidenum">
               <a:rPr lang="en-US" smtClean="0"/>
-              <a:t>‹#›</a:t>
+              <a:t>‹Nr.›</a:t>
             </a:fld>
             <a:endParaRPr lang="en-US"/>
           </a:p>
@@ -1451,10 +1455,9 @@
           </a:lstStyle>
           <a:p>
             <a:r>
-              <a:rPr lang="en-US" smtClean="0"/>
+              <a:rPr lang="en-US"/>
               <a:t>Click to edit Master title style</a:t>
             </a:r>
-            <a:endParaRPr lang="en-US"/>
           </a:p>
         </p:txBody>
       </p:sp>
@@ -1517,7 +1520,7 @@
           <a:p>
             <a:pPr lvl="0"/>
             <a:r>
-              <a:rPr lang="en-US" smtClean="0"/>
+              <a:rPr lang="en-US"/>
               <a:t>Click to edit Master text styles</a:t>
             </a:r>
           </a:p>
@@ -1573,38 +1576,37 @@
           <a:p>
             <a:pPr lvl="0"/>
             <a:r>
-              <a:rPr lang="en-US" smtClean="0"/>
+              <a:rPr lang="en-US"/>
               <a:t>Click to edit Master text styles</a:t>
             </a:r>
           </a:p>
           <a:p>
             <a:pPr lvl="1"/>
             <a:r>
-              <a:rPr lang="en-US" smtClean="0"/>
+              <a:rPr lang="en-US"/>
               <a:t>Second level</a:t>
             </a:r>
           </a:p>
           <a:p>
             <a:pPr lvl="2"/>
             <a:r>
-              <a:rPr lang="en-US" smtClean="0"/>
+              <a:rPr lang="en-US"/>
               <a:t>Third level</a:t>
             </a:r>
           </a:p>
           <a:p>
             <a:pPr lvl="3"/>
             <a:r>
-              <a:rPr lang="en-US" smtClean="0"/>
+              <a:rPr lang="en-US"/>
               <a:t>Fourth level</a:t>
             </a:r>
           </a:p>
           <a:p>
             <a:pPr lvl="4"/>
             <a:r>
-              <a:rPr lang="en-US" smtClean="0"/>
+              <a:rPr lang="en-US"/>
               <a:t>Fifth level</a:t>
             </a:r>
-            <a:endParaRPr lang="en-US"/>
           </a:p>
         </p:txBody>
       </p:sp>
@@ -1667,7 +1669,7 @@
           <a:p>
             <a:pPr lvl="0"/>
             <a:r>
-              <a:rPr lang="en-US" smtClean="0"/>
+              <a:rPr lang="en-US"/>
               <a:t>Click to edit Master text styles</a:t>
             </a:r>
           </a:p>
@@ -1723,38 +1725,37 @@
           <a:p>
             <a:pPr lvl="0"/>
             <a:r>
-              <a:rPr lang="en-US" smtClean="0"/>
+              <a:rPr lang="en-US"/>
               <a:t>Click to edit Master text styles</a:t>
             </a:r>
           </a:p>
           <a:p>
             <a:pPr lvl="1"/>
             <a:r>
-              <a:rPr lang="en-US" smtClean="0"/>
+              <a:rPr lang="en-US"/>
               <a:t>Second level</a:t>
             </a:r>
           </a:p>
           <a:p>
             <a:pPr lvl="2"/>
             <a:r>
-              <a:rPr lang="en-US" smtClean="0"/>
+              <a:rPr lang="en-US"/>
               <a:t>Third level</a:t>
             </a:r>
           </a:p>
           <a:p>
             <a:pPr lvl="3"/>
             <a:r>
-              <a:rPr lang="en-US" smtClean="0"/>
+              <a:rPr lang="en-US"/>
               <a:t>Fourth level</a:t>
             </a:r>
           </a:p>
           <a:p>
             <a:pPr lvl="4"/>
             <a:r>
-              <a:rPr lang="en-US" smtClean="0"/>
+              <a:rPr lang="en-US"/>
               <a:t>Fifth level</a:t>
             </a:r>
-            <a:endParaRPr lang="en-US"/>
           </a:p>
         </p:txBody>
       </p:sp>
@@ -1775,7 +1776,7 @@
           <a:p>
             <a:fld id="{5BCAD085-E8A6-8845-BD4E-CB4CCA059FC4}" type="datetimeFigureOut">
               <a:rPr lang="en-US" smtClean="0"/>
-              <a:t>1/27/13</a:t>
+              <a:t>4/13/26</a:t>
             </a:fld>
             <a:endParaRPr lang="en-US"/>
           </a:p>
@@ -1817,7 +1818,7 @@
           <a:p>
             <a:fld id="{C1FF6DA9-008F-8B48-92A6-B652298478BF}" type="slidenum">
               <a:rPr lang="en-US" smtClean="0"/>
-              <a:t>‹#›</a:t>
+              <a:t>‹Nr.›</a:t>
             </a:fld>
             <a:endParaRPr lang="en-US"/>
           </a:p>
@@ -1869,10 +1870,9 @@
           <a:lstStyle/>
           <a:p>
             <a:r>
-              <a:rPr lang="en-US" smtClean="0"/>
+              <a:rPr lang="en-US"/>
               <a:t>Click to edit Master title style</a:t>
             </a:r>
-            <a:endParaRPr lang="en-US"/>
           </a:p>
         </p:txBody>
       </p:sp>
@@ -1893,7 +1893,7 @@
           <a:p>
             <a:fld id="{5BCAD085-E8A6-8845-BD4E-CB4CCA059FC4}" type="datetimeFigureOut">
               <a:rPr lang="en-US" smtClean="0"/>
-              <a:t>1/27/13</a:t>
+              <a:t>4/13/26</a:t>
             </a:fld>
             <a:endParaRPr lang="en-US"/>
           </a:p>
@@ -1935,7 +1935,7 @@
           <a:p>
             <a:fld id="{C1FF6DA9-008F-8B48-92A6-B652298478BF}" type="slidenum">
               <a:rPr lang="en-US" smtClean="0"/>
-              <a:t>‹#›</a:t>
+              <a:t>‹Nr.›</a:t>
             </a:fld>
             <a:endParaRPr lang="en-US"/>
           </a:p>
@@ -1988,7 +1988,7 @@
           <a:p>
             <a:fld id="{5BCAD085-E8A6-8845-BD4E-CB4CCA059FC4}" type="datetimeFigureOut">
               <a:rPr lang="en-US" smtClean="0"/>
-              <a:t>1/27/13</a:t>
+              <a:t>4/13/26</a:t>
             </a:fld>
             <a:endParaRPr lang="en-US"/>
           </a:p>
@@ -2030,7 +2030,7 @@
           <a:p>
             <a:fld id="{C1FF6DA9-008F-8B48-92A6-B652298478BF}" type="slidenum">
               <a:rPr lang="en-US" smtClean="0"/>
-              <a:t>‹#›</a:t>
+              <a:t>‹Nr.›</a:t>
             </a:fld>
             <a:endParaRPr lang="en-US"/>
           </a:p>
@@ -2091,10 +2091,9 @@
           </a:lstStyle>
           <a:p>
             <a:r>
-              <a:rPr lang="en-US" smtClean="0"/>
+              <a:rPr lang="en-US"/>
               <a:t>Click to edit Master title style</a:t>
             </a:r>
-            <a:endParaRPr lang="en-US"/>
           </a:p>
         </p:txBody>
       </p:sp>
@@ -2148,38 +2147,37 @@
           <a:p>
             <a:pPr lvl="0"/>
             <a:r>
-              <a:rPr lang="en-US" smtClean="0"/>
+              <a:rPr lang="en-US"/>
               <a:t>Click to edit Master text styles</a:t>
             </a:r>
           </a:p>
           <a:p>
             <a:pPr lvl="1"/>
             <a:r>
-              <a:rPr lang="en-US" smtClean="0"/>
+              <a:rPr lang="en-US"/>
               <a:t>Second level</a:t>
             </a:r>
           </a:p>
           <a:p>
             <a:pPr lvl="2"/>
             <a:r>
-              <a:rPr lang="en-US" smtClean="0"/>
+              <a:rPr lang="en-US"/>
               <a:t>Third level</a:t>
             </a:r>
           </a:p>
           <a:p>
             <a:pPr lvl="3"/>
             <a:r>
-              <a:rPr lang="en-US" smtClean="0"/>
+              <a:rPr lang="en-US"/>
               <a:t>Fourth level</a:t>
             </a:r>
           </a:p>
           <a:p>
             <a:pPr lvl="4"/>
             <a:r>
-              <a:rPr lang="en-US" smtClean="0"/>
+              <a:rPr lang="en-US"/>
               <a:t>Fifth level</a:t>
             </a:r>
-            <a:endParaRPr lang="en-US"/>
           </a:p>
         </p:txBody>
       </p:sp>
@@ -2242,7 +2240,7 @@
           <a:p>
             <a:pPr lvl="0"/>
             <a:r>
-              <a:rPr lang="en-US" smtClean="0"/>
+              <a:rPr lang="en-US"/>
               <a:t>Click to edit Master text styles</a:t>
             </a:r>
           </a:p>
@@ -2265,7 +2263,7 @@
           <a:p>
             <a:fld id="{5BCAD085-E8A6-8845-BD4E-CB4CCA059FC4}" type="datetimeFigureOut">
               <a:rPr lang="en-US" smtClean="0"/>
-              <a:t>1/27/13</a:t>
+              <a:t>4/13/26</a:t>
             </a:fld>
             <a:endParaRPr lang="en-US"/>
           </a:p>
@@ -2307,7 +2305,7 @@
           <a:p>
             <a:fld id="{C1FF6DA9-008F-8B48-92A6-B652298478BF}" type="slidenum">
               <a:rPr lang="en-US" smtClean="0"/>
-              <a:t>‹#›</a:t>
+              <a:t>‹Nr.›</a:t>
             </a:fld>
             <a:endParaRPr lang="en-US"/>
           </a:p>
@@ -2368,10 +2366,9 @@
           </a:lstStyle>
           <a:p>
             <a:r>
-              <a:rPr lang="en-US" smtClean="0"/>
+              <a:rPr lang="en-US"/>
               <a:t>Click to edit Master title style</a:t>
             </a:r>
-            <a:endParaRPr lang="en-US"/>
           </a:p>
         </p:txBody>
       </p:sp>
@@ -2495,7 +2492,7 @@
           <a:p>
             <a:pPr lvl="0"/>
             <a:r>
-              <a:rPr lang="en-US" smtClean="0"/>
+              <a:rPr lang="en-US"/>
               <a:t>Click to edit Master text styles</a:t>
             </a:r>
           </a:p>
@@ -2518,7 +2515,7 @@
           <a:p>
             <a:fld id="{5BCAD085-E8A6-8845-BD4E-CB4CCA059FC4}" type="datetimeFigureOut">
               <a:rPr lang="en-US" smtClean="0"/>
-              <a:t>1/27/13</a:t>
+              <a:t>4/13/26</a:t>
             </a:fld>
             <a:endParaRPr lang="en-US"/>
           </a:p>
@@ -2560,7 +2557,7 @@
           <a:p>
             <a:fld id="{C1FF6DA9-008F-8B48-92A6-B652298478BF}" type="slidenum">
               <a:rPr lang="en-US" smtClean="0"/>
-              <a:t>‹#›</a:t>
+              <a:t>‹Nr.›</a:t>
             </a:fld>
             <a:endParaRPr lang="en-US"/>
           </a:p>
@@ -2627,10 +2624,9 @@
           <a:lstStyle/>
           <a:p>
             <a:r>
-              <a:rPr lang="en-US" smtClean="0"/>
+              <a:rPr lang="en-US"/>
               <a:t>Click to edit Master title style</a:t>
             </a:r>
-            <a:endParaRPr lang="en-US"/>
           </a:p>
         </p:txBody>
       </p:sp>
@@ -2661,38 +2657,37 @@
           <a:p>
             <a:pPr lvl="0"/>
             <a:r>
-              <a:rPr lang="en-US" smtClean="0"/>
+              <a:rPr lang="en-US"/>
               <a:t>Click to edit Master text styles</a:t>
             </a:r>
           </a:p>
           <a:p>
             <a:pPr lvl="1"/>
             <a:r>
-              <a:rPr lang="en-US" smtClean="0"/>
+              <a:rPr lang="en-US"/>
               <a:t>Second level</a:t>
             </a:r>
           </a:p>
           <a:p>
             <a:pPr lvl="2"/>
             <a:r>
-              <a:rPr lang="en-US" smtClean="0"/>
+              <a:rPr lang="en-US"/>
               <a:t>Third level</a:t>
             </a:r>
           </a:p>
           <a:p>
             <a:pPr lvl="3"/>
             <a:r>
-              <a:rPr lang="en-US" smtClean="0"/>
+              <a:rPr lang="en-US"/>
               <a:t>Fourth level</a:t>
             </a:r>
           </a:p>
           <a:p>
             <a:pPr lvl="4"/>
             <a:r>
-              <a:rPr lang="en-US" smtClean="0"/>
+              <a:rPr lang="en-US"/>
               <a:t>Fifth level</a:t>
             </a:r>
-            <a:endParaRPr lang="en-US"/>
           </a:p>
         </p:txBody>
       </p:sp>
@@ -2731,7 +2726,7 @@
           <a:p>
             <a:fld id="{5BCAD085-E8A6-8845-BD4E-CB4CCA059FC4}" type="datetimeFigureOut">
               <a:rPr lang="en-US" smtClean="0"/>
-              <a:t>1/27/13</a:t>
+              <a:t>4/13/26</a:t>
             </a:fld>
             <a:endParaRPr lang="en-US"/>
           </a:p>
@@ -2809,7 +2804,7 @@
           <a:p>
             <a:fld id="{C1FF6DA9-008F-8B48-92A6-B652298478BF}" type="slidenum">
               <a:rPr lang="en-US" smtClean="0"/>
-              <a:t>‹#›</a:t>
+              <a:t>‹Nr.›</a:t>
             </a:fld>
             <a:endParaRPr lang="en-US"/>
           </a:p>
@@ -3090,7 +3085,7 @@
 </file>
 
 <file path=ppt/slides/slide1.xml><?xml version="1.0" encoding="utf-8"?>
-<p:sld xmlns:a="http://schemas.openxmlformats.org/drawingml/2006/main" xmlns:p="http://schemas.openxmlformats.org/presentationml/2006/main" xmlns:r="http://schemas.openxmlformats.org/officeDocument/2006/relationships">
+<p:sld xmlns:a="http://schemas.openxmlformats.org/drawingml/2006/main" xmlns:r="http://schemas.openxmlformats.org/officeDocument/2006/relationships" xmlns:p="http://schemas.openxmlformats.org/presentationml/2006/main">
   <p:cSld>
     <p:bg>
       <p:bgPr>
@@ -3106,7 +3101,14 @@
         <p:cNvGrpSpPr/>
         <p:nvPr/>
       </p:nvGrpSpPr>
-      <p:grpSpPr/>
+      <p:grpSpPr>
+        <a:xfrm>
+          <a:off x="0" y="0"/>
+          <a:ext cx="0" cy="0"/>
+          <a:chOff x="0" y="0"/>
+          <a:chExt cx="0" cy="0"/>
+        </a:xfrm>
+      </p:grpSpPr>
       <p:sp>
         <p:nvSpPr>
           <p:cNvPr id="2" name="Rectangle 1"/>
@@ -3147,6 +3149,7 @@
           <a:lstStyle/>
           <a:p>
             <a:pPr algn="ctr"/>
+            <a:endParaRPr/>
           </a:p>
         </p:txBody>
       </p:sp>
@@ -3267,7 +3270,7 @@
 </file>
 
 <file path=ppt/slides/slide10.xml><?xml version="1.0" encoding="utf-8"?>
-<p:sld xmlns:a="http://schemas.openxmlformats.org/drawingml/2006/main" xmlns:p="http://schemas.openxmlformats.org/presentationml/2006/main" xmlns:r="http://schemas.openxmlformats.org/officeDocument/2006/relationships">
+<p:sld xmlns:a="http://schemas.openxmlformats.org/drawingml/2006/main" xmlns:r="http://schemas.openxmlformats.org/officeDocument/2006/relationships" xmlns:p="http://schemas.openxmlformats.org/presentationml/2006/main">
   <p:cSld>
     <p:bg>
       <p:bgPr>
@@ -3283,7 +3286,14 @@
         <p:cNvGrpSpPr/>
         <p:nvPr/>
       </p:nvGrpSpPr>
-      <p:grpSpPr/>
+      <p:grpSpPr>
+        <a:xfrm>
+          <a:off x="0" y="0"/>
+          <a:ext cx="0" cy="0"/>
+          <a:chOff x="0" y="0"/>
+          <a:chExt cx="0" cy="0"/>
+        </a:xfrm>
+      </p:grpSpPr>
       <p:sp>
         <p:nvSpPr>
           <p:cNvPr id="2" name="TextBox 1"/>
@@ -3360,6 +3370,7 @@
           <a:lstStyle/>
           <a:p>
             <a:pPr algn="ctr"/>
+            <a:endParaRPr/>
           </a:p>
         </p:txBody>
       </p:sp>
@@ -3587,7 +3598,7 @@
         </p:nvSpPr>
         <p:spPr>
           <a:xfrm>
-            <a:off x="914400" y="3200400"/>
+            <a:off x="914400" y="3200399"/>
             <a:ext cx="457200" cy="457200"/>
           </a:xfrm>
           <a:prstGeom prst="rect">
@@ -3623,7 +3634,7 @@
         </p:nvSpPr>
         <p:spPr>
           <a:xfrm>
-            <a:off x="1371600" y="3200400"/>
+            <a:off x="1371600" y="3200399"/>
             <a:ext cx="9601200" cy="457200"/>
           </a:xfrm>
           <a:prstGeom prst="rect">
@@ -3659,7 +3670,7 @@
         </p:nvSpPr>
         <p:spPr>
           <a:xfrm>
-            <a:off x="914400" y="3749039"/>
+            <a:off x="914400" y="3749040"/>
             <a:ext cx="457200" cy="457200"/>
           </a:xfrm>
           <a:prstGeom prst="rect">
@@ -3695,7 +3706,7 @@
         </p:nvSpPr>
         <p:spPr>
           <a:xfrm>
-            <a:off x="1371600" y="3749039"/>
+            <a:off x="1371600" y="3749040"/>
             <a:ext cx="9601200" cy="457200"/>
           </a:xfrm>
           <a:prstGeom prst="rect">
@@ -3803,7 +3814,7 @@
         </p:nvSpPr>
         <p:spPr>
           <a:xfrm>
-            <a:off x="914400" y="4846320"/>
+            <a:off x="914400" y="4846319"/>
             <a:ext cx="457200" cy="457200"/>
           </a:xfrm>
           <a:prstGeom prst="rect">
@@ -3839,7 +3850,7 @@
         </p:nvSpPr>
         <p:spPr>
           <a:xfrm>
-            <a:off x="1371600" y="4846320"/>
+            <a:off x="1371600" y="4846319"/>
             <a:ext cx="9601200" cy="457200"/>
           </a:xfrm>
           <a:prstGeom prst="rect">
@@ -3984,7 +3995,7 @@
 </file>
 
 <file path=ppt/slides/slide11.xml><?xml version="1.0" encoding="utf-8"?>
-<p:sld xmlns:a="http://schemas.openxmlformats.org/drawingml/2006/main" xmlns:p="http://schemas.openxmlformats.org/presentationml/2006/main" xmlns:r="http://schemas.openxmlformats.org/officeDocument/2006/relationships">
+<p:sld xmlns:a="http://schemas.openxmlformats.org/drawingml/2006/main" xmlns:r="http://schemas.openxmlformats.org/officeDocument/2006/relationships" xmlns:p="http://schemas.openxmlformats.org/presentationml/2006/main">
   <p:cSld>
     <p:bg>
       <p:bgPr>
@@ -4000,7 +4011,14 @@
         <p:cNvGrpSpPr/>
         <p:nvPr/>
       </p:nvGrpSpPr>
-      <p:grpSpPr/>
+      <p:grpSpPr>
+        <a:xfrm>
+          <a:off x="0" y="0"/>
+          <a:ext cx="0" cy="0"/>
+          <a:chOff x="0" y="0"/>
+          <a:chExt cx="0" cy="0"/>
+        </a:xfrm>
+      </p:grpSpPr>
       <p:sp>
         <p:nvSpPr>
           <p:cNvPr id="2" name="TextBox 1"/>
@@ -4077,6 +4095,7 @@
           <a:lstStyle/>
           <a:p>
             <a:pPr algn="ctr"/>
+            <a:endParaRPr/>
           </a:p>
         </p:txBody>
       </p:sp>
@@ -4160,7 +4179,7 @@
         </p:nvSpPr>
         <p:spPr>
           <a:xfrm>
-            <a:off x="1188720" y="1874519"/>
+            <a:off x="1188720" y="1874520"/>
             <a:ext cx="9601200" cy="548640"/>
           </a:xfrm>
           <a:prstGeom prst="rect">
@@ -4341,7 +4360,7 @@
         <p:spPr>
           <a:xfrm>
             <a:off x="1188720" y="3383280"/>
-            <a:ext cx="2743200" cy="365760"/>
+            <a:ext cx="4528908" cy="365760"/>
           </a:xfrm>
           <a:prstGeom prst="rect">
             <a:avLst/>
@@ -4448,8 +4467,8 @@
         </p:nvSpPr>
         <p:spPr>
           <a:xfrm>
-            <a:off x="1188720" y="4297680"/>
-            <a:ext cx="2743200" cy="365760"/>
+            <a:off x="1188719" y="4297680"/>
+            <a:ext cx="5790149" cy="365760"/>
           </a:xfrm>
           <a:prstGeom prst="rect">
             <a:avLst/>
@@ -4471,7 +4490,24 @@
               </a:defRPr>
             </a:pPr>
             <a:r>
-              <a:t>Du brauchst jemanden für die Produktion.</a:t>
+              <a:rPr dirty="0"/>
+              <a:t>Du </a:t>
+            </a:r>
+            <a:r>
+              <a:rPr dirty="0" err="1"/>
+              <a:t>brauchst</a:t>
+            </a:r>
+            <a:r>
+              <a:rPr dirty="0"/>
+              <a:t> </a:t>
+            </a:r>
+            <a:r>
+              <a:rPr dirty="0" err="1"/>
+              <a:t>jemanden</a:t>
+            </a:r>
+            <a:r>
+              <a:rPr dirty="0"/>
+              <a:t> für die Produktion.</a:t>
             </a:r>
           </a:p>
         </p:txBody>
@@ -4556,8 +4592,8 @@
         </p:nvSpPr>
         <p:spPr>
           <a:xfrm>
-            <a:off x="1188720" y="5212080"/>
-            <a:ext cx="2743200" cy="365760"/>
+            <a:off x="1188719" y="5212080"/>
+            <a:ext cx="4812687" cy="365760"/>
           </a:xfrm>
           <a:prstGeom prst="rect">
             <a:avLst/>
@@ -4579,7 +4615,28 @@
               </a:defRPr>
             </a:pPr>
             <a:r>
-              <a:t>Nachfrage ist eine Wette.</a:t>
+              <a:rPr dirty="0" err="1"/>
+              <a:t>Nachfrage</a:t>
+            </a:r>
+            <a:r>
+              <a:rPr dirty="0"/>
+              <a:t> </a:t>
+            </a:r>
+            <a:r>
+              <a:rPr dirty="0" err="1"/>
+              <a:t>ist</a:t>
+            </a:r>
+            <a:r>
+              <a:rPr dirty="0"/>
+              <a:t> </a:t>
+            </a:r>
+            <a:r>
+              <a:rPr dirty="0" err="1"/>
+              <a:t>eine</a:t>
+            </a:r>
+            <a:r>
+              <a:rPr dirty="0"/>
+              <a:t> Wette.</a:t>
             </a:r>
           </a:p>
         </p:txBody>
@@ -4629,7 +4686,7 @@
 </file>
 
 <file path=ppt/slides/slide12.xml><?xml version="1.0" encoding="utf-8"?>
-<p:sld xmlns:a="http://schemas.openxmlformats.org/drawingml/2006/main" xmlns:p="http://schemas.openxmlformats.org/presentationml/2006/main" xmlns:r="http://schemas.openxmlformats.org/officeDocument/2006/relationships">
+<p:sld xmlns:a="http://schemas.openxmlformats.org/drawingml/2006/main" xmlns:r="http://schemas.openxmlformats.org/officeDocument/2006/relationships" xmlns:p="http://schemas.openxmlformats.org/presentationml/2006/main">
   <p:cSld>
     <p:bg>
       <p:bgPr>
@@ -4645,7 +4702,14 @@
         <p:cNvGrpSpPr/>
         <p:nvPr/>
       </p:nvGrpSpPr>
-      <p:grpSpPr/>
+      <p:grpSpPr>
+        <a:xfrm>
+          <a:off x="0" y="0"/>
+          <a:ext cx="0" cy="0"/>
+          <a:chOff x="0" y="0"/>
+          <a:chExt cx="0" cy="0"/>
+        </a:xfrm>
+      </p:grpSpPr>
       <p:sp>
         <p:nvSpPr>
           <p:cNvPr id="2" name="TextBox 1"/>
@@ -4722,6 +4786,7 @@
           <a:lstStyle/>
           <a:p>
             <a:pPr algn="ctr"/>
+            <a:endParaRPr/>
           </a:p>
         </p:txBody>
       </p:sp>
@@ -4790,6 +4855,7 @@
                 <a:latin typeface="Georgia"/>
               </a:defRPr>
             </a:pPr>
+            <a:endParaRPr/>
           </a:p>
           <a:p>
             <a:pPr>
@@ -4817,7 +4883,7 @@
         </p:nvSpPr>
         <p:spPr>
           <a:xfrm>
-            <a:off x="1371600" y="3474720"/>
+            <a:off x="1371600" y="3657600"/>
             <a:ext cx="9418320" cy="1828800"/>
           </a:xfrm>
           <a:prstGeom prst="rect">
@@ -4849,6 +4915,7 @@
           <a:lstStyle/>
           <a:p>
             <a:pPr algn="ctr"/>
+            <a:endParaRPr/>
           </a:p>
         </p:txBody>
       </p:sp>
@@ -4860,7 +4927,7 @@
         </p:nvSpPr>
         <p:spPr>
           <a:xfrm>
-            <a:off x="1645920" y="3657600"/>
+            <a:off x="1645920" y="3749040"/>
             <a:ext cx="8869680" cy="1645920"/>
           </a:xfrm>
           <a:prstGeom prst="rect">
@@ -4886,7 +4953,24 @@
               </a:defRPr>
             </a:pPr>
             <a:r>
-              <a:t>"Guten Tag, ich bin Silvio Brunetti vom Ristorante Goldoni.</a:t>
+              <a:rPr dirty="0"/>
+              <a:t>"</a:t>
+            </a:r>
+            <a:r>
+              <a:rPr dirty="0" err="1"/>
+              <a:t>Guten</a:t>
+            </a:r>
+            <a:r>
+              <a:rPr dirty="0"/>
+              <a:t> Tag, ich bin Silvio Brunetti </a:t>
+            </a:r>
+            <a:r>
+              <a:rPr dirty="0" err="1"/>
+              <a:t>vom</a:t>
+            </a:r>
+            <a:r>
+              <a:rPr dirty="0"/>
+              <a:t> Ristorante Goldoni.</a:t>
             </a:r>
           </a:p>
           <a:p>
@@ -4902,8 +4986,38 @@
               </a:defRPr>
             </a:pPr>
             <a:r>
-              <a:t>Ich möchte zusätzlich vakuumierte Speisen</a:t>
-            </a:r>
+              <a:rPr dirty="0"/>
+              <a:t>Ich </a:t>
+            </a:r>
+            <a:r>
+              <a:rPr dirty="0" err="1"/>
+              <a:t>möchte</a:t>
+            </a:r>
+            <a:r>
+              <a:rPr dirty="0"/>
+              <a:t> </a:t>
+            </a:r>
+            <a:r>
+              <a:rPr dirty="0" err="1"/>
+              <a:t>zusätzlich</a:t>
+            </a:r>
+            <a:r>
+              <a:rPr dirty="0"/>
+              <a:t> </a:t>
+            </a:r>
+            <a:r>
+              <a:rPr dirty="0" err="1"/>
+              <a:t>vakuumierte</a:t>
+            </a:r>
+            <a:r>
+              <a:rPr dirty="0"/>
+              <a:t> </a:t>
+            </a:r>
+            <a:r>
+              <a:rPr dirty="0" err="1"/>
+              <a:t>Speisen</a:t>
+            </a:r>
+            <a:endParaRPr dirty="0"/>
           </a:p>
           <a:p>
             <a:pPr>
@@ -4918,7 +5032,28 @@
               </a:defRPr>
             </a:pPr>
             <a:r>
-              <a:t>zum Mitnehmen anbieten.</a:t>
+              <a:rPr dirty="0" err="1"/>
+              <a:t>zum</a:t>
+            </a:r>
+            <a:r>
+              <a:rPr dirty="0"/>
+              <a:t> </a:t>
+            </a:r>
+            <a:r>
+              <a:rPr dirty="0" err="1"/>
+              <a:t>Mitnehmen</a:t>
+            </a:r>
+            <a:r>
+              <a:rPr dirty="0"/>
+              <a:t> </a:t>
+            </a:r>
+            <a:r>
+              <a:rPr dirty="0" err="1"/>
+              <a:t>anbieten</a:t>
+            </a:r>
+            <a:r>
+              <a:rPr dirty="0"/>
+              <a:t>.</a:t>
             </a:r>
           </a:p>
           <a:p>
@@ -4934,7 +5069,36 @@
               </a:defRPr>
             </a:pPr>
             <a:r>
-              <a:t>Können Sie mir sagen, was ich dafür brauche?"</a:t>
+              <a:rPr dirty="0" err="1"/>
+              <a:t>Können</a:t>
+            </a:r>
+            <a:r>
+              <a:rPr dirty="0"/>
+              <a:t> Sie mir </a:t>
+            </a:r>
+            <a:r>
+              <a:rPr dirty="0" err="1"/>
+              <a:t>sagen</a:t>
+            </a:r>
+            <a:r>
+              <a:rPr dirty="0"/>
+              <a:t>, was ich </a:t>
+            </a:r>
+            <a:r>
+              <a:rPr dirty="0" err="1"/>
+              <a:t>dafür</a:t>
+            </a:r>
+            <a:r>
+              <a:rPr dirty="0"/>
+              <a:t> </a:t>
+            </a:r>
+            <a:r>
+              <a:rPr dirty="0" err="1"/>
+              <a:t>brauche</a:t>
+            </a:r>
+            <a:r>
+              <a:rPr dirty="0"/>
+              <a:t>?"</a:t>
             </a:r>
           </a:p>
         </p:txBody>
@@ -4962,7 +5126,7 @@
           <a:lstStyle/>
           <a:p>
             <a:pPr algn="l">
-              <a:defRPr sz="1800" b="1">
+              <a:defRPr sz="1800" b="0">
                 <a:solidFill>
                   <a:srgbClr val="C8A25C"/>
                 </a:solidFill>
@@ -4970,7 +5134,80 @@
               </a:defRPr>
             </a:pPr>
             <a:r>
-              <a:t>Eine Nummer, eine Frage, zehn Minuten. Alles andere kommt danach — und alles andere bereite ich vor.</a:t>
+              <a:rPr dirty="0"/>
+              <a:t>Eine Nummer, </a:t>
+            </a:r>
+            <a:r>
+              <a:rPr dirty="0" err="1"/>
+              <a:t>eine</a:t>
+            </a:r>
+            <a:r>
+              <a:rPr dirty="0"/>
+              <a:t> Frage, </a:t>
+            </a:r>
+            <a:r>
+              <a:rPr dirty="0" err="1"/>
+              <a:t>zehn</a:t>
+            </a:r>
+            <a:r>
+              <a:rPr dirty="0"/>
+              <a:t> Minuten. Alles </a:t>
+            </a:r>
+            <a:r>
+              <a:rPr dirty="0" err="1"/>
+              <a:t>andere</a:t>
+            </a:r>
+            <a:r>
+              <a:rPr dirty="0"/>
+              <a:t> </a:t>
+            </a:r>
+            <a:r>
+              <a:rPr dirty="0" err="1"/>
+              <a:t>kommt</a:t>
+            </a:r>
+            <a:r>
+              <a:rPr dirty="0"/>
+              <a:t> </a:t>
+            </a:r>
+            <a:r>
+              <a:rPr dirty="0" err="1"/>
+              <a:t>danach</a:t>
+            </a:r>
+            <a:r>
+              <a:rPr dirty="0"/>
+              <a:t> — und </a:t>
+            </a:r>
+            <a:r>
+              <a:rPr dirty="0" err="1"/>
+              <a:t>alles</a:t>
+            </a:r>
+            <a:r>
+              <a:rPr dirty="0"/>
+              <a:t> </a:t>
+            </a:r>
+            <a:r>
+              <a:rPr dirty="0" err="1"/>
+              <a:t>andere</a:t>
+            </a:r>
+            <a:r>
+              <a:rPr dirty="0"/>
+              <a:t> </a:t>
+            </a:r>
+            <a:r>
+              <a:rPr dirty="0" err="1"/>
+              <a:t>bereite</a:t>
+            </a:r>
+            <a:r>
+              <a:rPr dirty="0"/>
+              <a:t> ich </a:t>
+            </a:r>
+            <a:r>
+              <a:rPr dirty="0" err="1"/>
+              <a:t>vor</a:t>
+            </a:r>
+            <a:r>
+              <a:rPr dirty="0"/>
+              <a:t>.</a:t>
             </a:r>
           </a:p>
         </p:txBody>
@@ -4984,7 +5221,7 @@
 </file>
 
 <file path=ppt/slides/slide2.xml><?xml version="1.0" encoding="utf-8"?>
-<p:sld xmlns:a="http://schemas.openxmlformats.org/drawingml/2006/main" xmlns:p="http://schemas.openxmlformats.org/presentationml/2006/main" xmlns:r="http://schemas.openxmlformats.org/officeDocument/2006/relationships">
+<p:sld xmlns:a="http://schemas.openxmlformats.org/drawingml/2006/main" xmlns:r="http://schemas.openxmlformats.org/officeDocument/2006/relationships" xmlns:p="http://schemas.openxmlformats.org/presentationml/2006/main">
   <p:cSld>
     <p:bg>
       <p:bgPr>
@@ -5000,7 +5237,14 @@
         <p:cNvGrpSpPr/>
         <p:nvPr/>
       </p:nvGrpSpPr>
-      <p:grpSpPr/>
+      <p:grpSpPr>
+        <a:xfrm>
+          <a:off x="0" y="0"/>
+          <a:ext cx="0" cy="0"/>
+          <a:chOff x="0" y="0"/>
+          <a:chExt cx="0" cy="0"/>
+        </a:xfrm>
+      </p:grpSpPr>
       <p:sp>
         <p:nvSpPr>
           <p:cNvPr id="2" name="TextBox 1"/>
@@ -5077,6 +5321,7 @@
           <a:lstStyle/>
           <a:p>
             <a:pPr algn="ctr"/>
+            <a:endParaRPr/>
           </a:p>
         </p:txBody>
       </p:sp>
@@ -5114,7 +5359,44 @@
               </a:defRPr>
             </a:pPr>
             <a:r>
-              <a:t>Deine Küche kocht jeden Tag Ragù, Sugo, Lasagne, Parmigiana —</a:t>
+              <a:rPr dirty="0" err="1"/>
+              <a:t>Deine</a:t>
+            </a:r>
+            <a:r>
+              <a:rPr dirty="0"/>
+              <a:t> </a:t>
+            </a:r>
+            <a:r>
+              <a:rPr dirty="0" err="1"/>
+              <a:t>Küche</a:t>
+            </a:r>
+            <a:r>
+              <a:rPr dirty="0"/>
+              <a:t> </a:t>
+            </a:r>
+            <a:r>
+              <a:rPr dirty="0" err="1"/>
+              <a:t>kocht</a:t>
+            </a:r>
+            <a:r>
+              <a:rPr dirty="0"/>
+              <a:t> </a:t>
+            </a:r>
+            <a:r>
+              <a:rPr dirty="0" err="1"/>
+              <a:t>jeden</a:t>
+            </a:r>
+            <a:r>
+              <a:rPr dirty="0"/>
+              <a:t> Tag Ragù, Sugo, </a:t>
+            </a:r>
+            <a:r>
+              <a:rPr dirty="0" err="1"/>
+              <a:t>Lasagne</a:t>
+            </a:r>
+            <a:r>
+              <a:rPr dirty="0"/>
+              <a:t>, Parmigiana —</a:t>
             </a:r>
           </a:p>
           <a:p>
@@ -5130,7 +5412,16 @@
               </a:defRPr>
             </a:pPr>
             <a:r>
-              <a:t>für die Gäste am Tisch.</a:t>
+              <a:rPr dirty="0"/>
+              <a:t>für die </a:t>
+            </a:r>
+            <a:r>
+              <a:rPr dirty="0" err="1"/>
+              <a:t>Gäste</a:t>
+            </a:r>
+            <a:r>
+              <a:rPr dirty="0"/>
+              <a:t> am Tisch.</a:t>
             </a:r>
           </a:p>
           <a:p>
@@ -5145,6 +5436,7 @@
                 <a:latin typeface="Georgia"/>
               </a:defRPr>
             </a:pPr>
+            <a:endParaRPr dirty="0"/>
           </a:p>
           <a:p>
             <a:pPr>
@@ -5159,8 +5451,46 @@
               </a:defRPr>
             </a:pPr>
             <a:r>
-              <a:t>Die Idee: einen Teil davon vakuumiert in den Kühlschrank packen</a:t>
-            </a:r>
+              <a:rPr dirty="0"/>
+              <a:t>Die Idee: </a:t>
+            </a:r>
+            <a:r>
+              <a:rPr dirty="0" err="1"/>
+              <a:t>einen</a:t>
+            </a:r>
+            <a:r>
+              <a:rPr dirty="0"/>
+              <a:t> Teil </a:t>
+            </a:r>
+            <a:r>
+              <a:rPr dirty="0" err="1"/>
+              <a:t>davon</a:t>
+            </a:r>
+            <a:r>
+              <a:rPr dirty="0"/>
+              <a:t> </a:t>
+            </a:r>
+            <a:r>
+              <a:rPr dirty="0" err="1"/>
+              <a:t>vakuumiert</a:t>
+            </a:r>
+            <a:r>
+              <a:rPr dirty="0"/>
+              <a:t> in den </a:t>
+            </a:r>
+            <a:r>
+              <a:rPr dirty="0" err="1"/>
+              <a:t>Kühlschrank</a:t>
+            </a:r>
+            <a:r>
+              <a:rPr dirty="0"/>
+              <a:t> </a:t>
+            </a:r>
+            <a:r>
+              <a:rPr dirty="0" err="1"/>
+              <a:t>packen</a:t>
+            </a:r>
+            <a:endParaRPr dirty="0"/>
           </a:p>
           <a:p>
             <a:pPr>
@@ -5175,7 +5505,40 @@
               </a:defRPr>
             </a:pPr>
             <a:r>
-              <a:t>und verkaufen. Zum Mitnehmen, zum Vorbestellen,</a:t>
+              <a:rPr dirty="0"/>
+              <a:t>und </a:t>
+            </a:r>
+            <a:r>
+              <a:rPr dirty="0" err="1"/>
+              <a:t>verkaufen</a:t>
+            </a:r>
+            <a:r>
+              <a:rPr dirty="0"/>
+              <a:t>. Zum </a:t>
+            </a:r>
+            <a:r>
+              <a:rPr dirty="0" err="1"/>
+              <a:t>Mitnehmen</a:t>
+            </a:r>
+            <a:r>
+              <a:rPr dirty="0"/>
+              <a:t>, </a:t>
+            </a:r>
+            <a:r>
+              <a:rPr dirty="0" err="1"/>
+              <a:t>zum</a:t>
+            </a:r>
+            <a:r>
+              <a:rPr dirty="0"/>
+              <a:t> </a:t>
+            </a:r>
+            <a:r>
+              <a:rPr dirty="0" err="1"/>
+              <a:t>Vorbestellen</a:t>
+            </a:r>
+            <a:r>
+              <a:rPr dirty="0"/>
+              <a:t>,</a:t>
             </a:r>
           </a:p>
           <a:p>
@@ -5191,7 +5554,12 @@
               </a:defRPr>
             </a:pPr>
             <a:r>
-              <a:t>über Wolt und Uber Eats.</a:t>
+              <a:rPr dirty="0" err="1"/>
+              <a:t>über</a:t>
+            </a:r>
+            <a:r>
+              <a:rPr dirty="0"/>
+              <a:t> Wolt und Uber Eats.</a:t>
             </a:r>
           </a:p>
           <a:p>
@@ -5206,6 +5574,7 @@
                 <a:latin typeface="Georgia"/>
               </a:defRPr>
             </a:pPr>
+            <a:endParaRPr dirty="0"/>
           </a:p>
           <a:p>
             <a:pPr>
@@ -5220,7 +5589,48 @@
               </a:defRPr>
             </a:pPr>
             <a:r>
-              <a:t>Kein neues Geschäft, keine neue Küche.</a:t>
+              <a:rPr dirty="0"/>
+              <a:t>Kein </a:t>
+            </a:r>
+            <a:r>
+              <a:rPr dirty="0" err="1"/>
+              <a:t>neues</a:t>
+            </a:r>
+            <a:r>
+              <a:rPr dirty="0"/>
+              <a:t> </a:t>
+            </a:r>
+            <a:r>
+              <a:rPr dirty="0" err="1"/>
+              <a:t>Geschäft</a:t>
+            </a:r>
+            <a:r>
+              <a:rPr dirty="0"/>
+              <a:t>, </a:t>
+            </a:r>
+            <a:r>
+              <a:rPr dirty="0" err="1"/>
+              <a:t>keine</a:t>
+            </a:r>
+            <a:r>
+              <a:rPr dirty="0"/>
+              <a:t> </a:t>
+            </a:r>
+            <a:r>
+              <a:rPr dirty="0" err="1"/>
+              <a:t>neue</a:t>
+            </a:r>
+            <a:r>
+              <a:rPr dirty="0"/>
+              <a:t> </a:t>
+            </a:r>
+            <a:r>
+              <a:rPr dirty="0" err="1"/>
+              <a:t>Küche</a:t>
+            </a:r>
+            <a:r>
+              <a:rPr dirty="0"/>
+              <a:t>.</a:t>
             </a:r>
           </a:p>
           <a:p>
@@ -5236,7 +5646,36 @@
               </a:defRPr>
             </a:pPr>
             <a:r>
-              <a:t>Dasselbe Essen, nur zusätzlich verpackt.</a:t>
+              <a:rPr dirty="0" err="1"/>
+              <a:t>Dasselbe</a:t>
+            </a:r>
+            <a:r>
+              <a:rPr dirty="0"/>
+              <a:t> Essen, </a:t>
+            </a:r>
+            <a:r>
+              <a:rPr dirty="0" err="1"/>
+              <a:t>nur</a:t>
+            </a:r>
+            <a:r>
+              <a:rPr dirty="0"/>
+              <a:t> </a:t>
+            </a:r>
+            <a:r>
+              <a:rPr dirty="0" err="1"/>
+              <a:t>zusätzlich</a:t>
+            </a:r>
+            <a:r>
+              <a:rPr dirty="0"/>
+              <a:t> </a:t>
+            </a:r>
+            <a:r>
+              <a:rPr dirty="0" err="1"/>
+              <a:t>verpackt</a:t>
+            </a:r>
+            <a:r>
+              <a:rPr dirty="0"/>
+              <a:t>.</a:t>
             </a:r>
           </a:p>
         </p:txBody>
@@ -5250,7 +5689,7 @@
 </file>
 
 <file path=ppt/slides/slide3.xml><?xml version="1.0" encoding="utf-8"?>
-<p:sld xmlns:a="http://schemas.openxmlformats.org/drawingml/2006/main" xmlns:p="http://schemas.openxmlformats.org/presentationml/2006/main" xmlns:r="http://schemas.openxmlformats.org/officeDocument/2006/relationships">
+<p:sld xmlns:a="http://schemas.openxmlformats.org/drawingml/2006/main" xmlns:r="http://schemas.openxmlformats.org/officeDocument/2006/relationships" xmlns:p="http://schemas.openxmlformats.org/presentationml/2006/main">
   <p:cSld>
     <p:bg>
       <p:bgPr>
@@ -5266,7 +5705,14 @@
         <p:cNvGrpSpPr/>
         <p:nvPr/>
       </p:nvGrpSpPr>
-      <p:grpSpPr/>
+      <p:grpSpPr>
+        <a:xfrm>
+          <a:off x="0" y="0"/>
+          <a:ext cx="0" cy="0"/>
+          <a:chOff x="0" y="0"/>
+          <a:chExt cx="0" cy="0"/>
+        </a:xfrm>
+      </p:grpSpPr>
       <p:sp>
         <p:nvSpPr>
           <p:cNvPr id="2" name="TextBox 1"/>
@@ -5343,6 +5789,7 @@
           <a:lstStyle/>
           <a:p>
             <a:pPr algn="ctr"/>
+            <a:endParaRPr/>
           </a:p>
         </p:txBody>
       </p:sp>
@@ -5426,7 +5873,7 @@
         <p:spPr>
           <a:xfrm>
             <a:off x="731520" y="3474720"/>
-            <a:ext cx="5029200" cy="457200"/>
+            <a:ext cx="5029200" cy="914400"/>
           </a:xfrm>
           <a:prstGeom prst="rect">
             <a:avLst/>
@@ -5439,7 +5886,10 @@
           </a:bodyPr>
           <a:lstStyle/>
           <a:p>
-            <a:pPr algn="l">
+            <a:pPr>
+              <a:spcAft>
+                <a:spcPts val="960"/>
+              </a:spcAft>
               <a:defRPr sz="2000" b="1">
                 <a:solidFill>
                   <a:srgbClr val="F5F0E6"/>
@@ -5472,9 +5922,27 @@
                 <a:tableStyleId>{5C22544A-7EE6-4342-B048-85BDC9FD1C3A}</a:tableStyleId>
               </a:tblPr>
               <a:tblGrid>
-                <a:gridCol w="3566160"/>
-                <a:gridCol w="3566160"/>
-                <a:gridCol w="3566160"/>
+                <a:gridCol w="3200400">
+                  <a:extLst>
+                    <a:ext uri="{9D8B030D-6E8A-4147-A177-3AD203B41FA5}">
+                      <a16:colId xmlns:a16="http://schemas.microsoft.com/office/drawing/2014/main" val="20000"/>
+                    </a:ext>
+                  </a:extLst>
+                </a:gridCol>
+                <a:gridCol w="4297680">
+                  <a:extLst>
+                    <a:ext uri="{9D8B030D-6E8A-4147-A177-3AD203B41FA5}">
+                      <a16:colId xmlns:a16="http://schemas.microsoft.com/office/drawing/2014/main" val="20001"/>
+                    </a:ext>
+                  </a:extLst>
+                </a:gridCol>
+                <a:gridCol w="3200400">
+                  <a:extLst>
+                    <a:ext uri="{9D8B030D-6E8A-4147-A177-3AD203B41FA5}">
+                      <a16:colId xmlns:a16="http://schemas.microsoft.com/office/drawing/2014/main" val="20002"/>
+                    </a:ext>
+                  </a:extLst>
+                </a:gridCol>
               </a:tblGrid>
               <a:tr h="411480">
                 <a:tc>
@@ -5549,6 +6017,11 @@
                     </a:solidFill>
                   </a:tcPr>
                 </a:tc>
+                <a:extLst>
+                  <a:ext uri="{0D108BD9-81ED-4DB2-BD59-A6C34878D82A}">
+                    <a16:rowId xmlns:a16="http://schemas.microsoft.com/office/drawing/2014/main" val="10000"/>
+                  </a:ext>
+                </a:extLst>
               </a:tr>
               <a:tr h="411480">
                 <a:tc>
@@ -5557,7 +6030,7 @@
                     <a:lstStyle/>
                     <a:p>
                       <a:pPr>
-                        <a:defRPr sz="1400">
+                        <a:defRPr sz="1400" b="0">
                           <a:solidFill>
                             <a:srgbClr val="F5F0E6"/>
                           </a:solidFill>
@@ -5581,7 +6054,7 @@
                     <a:lstStyle/>
                     <a:p>
                       <a:pPr>
-                        <a:defRPr sz="1400">
+                        <a:defRPr sz="1400" b="0">
                           <a:solidFill>
                             <a:srgbClr val="F5F0E6"/>
                           </a:solidFill>
@@ -5605,7 +6078,7 @@
                     <a:lstStyle/>
                     <a:p>
                       <a:pPr>
-                        <a:defRPr sz="1400">
+                        <a:defRPr sz="1400" b="0">
                           <a:solidFill>
                             <a:srgbClr val="F5F0E6"/>
                           </a:solidFill>
@@ -5623,6 +6096,11 @@
                     </a:solidFill>
                   </a:tcPr>
                 </a:tc>
+                <a:extLst>
+                  <a:ext uri="{0D108BD9-81ED-4DB2-BD59-A6C34878D82A}">
+                    <a16:rowId xmlns:a16="http://schemas.microsoft.com/office/drawing/2014/main" val="10001"/>
+                  </a:ext>
+                </a:extLst>
               </a:tr>
               <a:tr h="411480">
                 <a:tc>
@@ -5631,7 +6109,7 @@
                     <a:lstStyle/>
                     <a:p>
                       <a:pPr>
-                        <a:defRPr sz="1400">
+                        <a:defRPr sz="1400" b="0">
                           <a:solidFill>
                             <a:srgbClr val="F5F0E6"/>
                           </a:solidFill>
@@ -5655,7 +6133,7 @@
                     <a:lstStyle/>
                     <a:p>
                       <a:pPr>
-                        <a:defRPr sz="1400">
+                        <a:defRPr sz="1400" b="0">
                           <a:solidFill>
                             <a:srgbClr val="F5F0E6"/>
                           </a:solidFill>
@@ -5679,7 +6157,7 @@
                     <a:lstStyle/>
                     <a:p>
                       <a:pPr>
-                        <a:defRPr sz="1400">
+                        <a:defRPr sz="1400" b="0">
                           <a:solidFill>
                             <a:srgbClr val="F5F0E6"/>
                           </a:solidFill>
@@ -5697,6 +6175,11 @@
                     </a:solidFill>
                   </a:tcPr>
                 </a:tc>
+                <a:extLst>
+                  <a:ext uri="{0D108BD9-81ED-4DB2-BD59-A6C34878D82A}">
+                    <a16:rowId xmlns:a16="http://schemas.microsoft.com/office/drawing/2014/main" val="10002"/>
+                  </a:ext>
+                </a:extLst>
               </a:tr>
             </a:tbl>
           </a:graphicData>
@@ -5747,7 +6230,7 @@
 </file>
 
 <file path=ppt/slides/slide4.xml><?xml version="1.0" encoding="utf-8"?>
-<p:sld xmlns:a="http://schemas.openxmlformats.org/drawingml/2006/main" xmlns:p="http://schemas.openxmlformats.org/presentationml/2006/main" xmlns:r="http://schemas.openxmlformats.org/officeDocument/2006/relationships">
+<p:sld xmlns:a="http://schemas.openxmlformats.org/drawingml/2006/main" xmlns:r="http://schemas.openxmlformats.org/officeDocument/2006/relationships" xmlns:p="http://schemas.openxmlformats.org/presentationml/2006/main">
   <p:cSld>
     <p:bg>
       <p:bgPr>
@@ -5763,7 +6246,14 @@
         <p:cNvGrpSpPr/>
         <p:nvPr/>
       </p:nvGrpSpPr>
-      <p:grpSpPr/>
+      <p:grpSpPr>
+        <a:xfrm>
+          <a:off x="0" y="0"/>
+          <a:ext cx="0" cy="0"/>
+          <a:chOff x="0" y="0"/>
+          <a:chExt cx="0" cy="0"/>
+        </a:xfrm>
+      </p:grpSpPr>
       <p:sp>
         <p:nvSpPr>
           <p:cNvPr id="2" name="TextBox 1"/>
@@ -5840,6 +6330,7 @@
           <a:lstStyle/>
           <a:p>
             <a:pPr algn="ctr"/>
+            <a:endParaRPr/>
           </a:p>
         </p:txBody>
       </p:sp>
@@ -6320,7 +6811,7 @@
 </file>
 
 <file path=ppt/slides/slide5.xml><?xml version="1.0" encoding="utf-8"?>
-<p:sld xmlns:a="http://schemas.openxmlformats.org/drawingml/2006/main" xmlns:p="http://schemas.openxmlformats.org/presentationml/2006/main" xmlns:r="http://schemas.openxmlformats.org/officeDocument/2006/relationships">
+<p:sld xmlns:a="http://schemas.openxmlformats.org/drawingml/2006/main" xmlns:r="http://schemas.openxmlformats.org/officeDocument/2006/relationships" xmlns:p="http://schemas.openxmlformats.org/presentationml/2006/main">
   <p:cSld>
     <p:bg>
       <p:bgPr>
@@ -6336,7 +6827,14 @@
         <p:cNvGrpSpPr/>
         <p:nvPr/>
       </p:nvGrpSpPr>
-      <p:grpSpPr/>
+      <p:grpSpPr>
+        <a:xfrm>
+          <a:off x="0" y="0"/>
+          <a:ext cx="0" cy="0"/>
+          <a:chOff x="0" y="0"/>
+          <a:chExt cx="0" cy="0"/>
+        </a:xfrm>
+      </p:grpSpPr>
       <p:sp>
         <p:nvSpPr>
           <p:cNvPr id="2" name="TextBox 1"/>
@@ -6413,6 +6911,7 @@
           <a:lstStyle/>
           <a:p>
             <a:pPr algn="ctr"/>
+            <a:endParaRPr/>
           </a:p>
         </p:txBody>
       </p:sp>
@@ -6435,10 +6934,34 @@
                 <a:tableStyleId>{5C22544A-7EE6-4342-B048-85BDC9FD1C3A}</a:tableStyleId>
               </a:tblPr>
               <a:tblGrid>
-                <a:gridCol w="2674620"/>
-                <a:gridCol w="2674620"/>
-                <a:gridCol w="2674620"/>
-                <a:gridCol w="2674620"/>
+                <a:gridCol w="3200400">
+                  <a:extLst>
+                    <a:ext uri="{9D8B030D-6E8A-4147-A177-3AD203B41FA5}">
+                      <a16:colId xmlns:a16="http://schemas.microsoft.com/office/drawing/2014/main" val="20000"/>
+                    </a:ext>
+                  </a:extLst>
+                </a:gridCol>
+                <a:gridCol w="2468880">
+                  <a:extLst>
+                    <a:ext uri="{9D8B030D-6E8A-4147-A177-3AD203B41FA5}">
+                      <a16:colId xmlns:a16="http://schemas.microsoft.com/office/drawing/2014/main" val="20001"/>
+                    </a:ext>
+                  </a:extLst>
+                </a:gridCol>
+                <a:gridCol w="2286000">
+                  <a:extLst>
+                    <a:ext uri="{9D8B030D-6E8A-4147-A177-3AD203B41FA5}">
+                      <a16:colId xmlns:a16="http://schemas.microsoft.com/office/drawing/2014/main" val="20002"/>
+                    </a:ext>
+                  </a:extLst>
+                </a:gridCol>
+                <a:gridCol w="2743200">
+                  <a:extLst>
+                    <a:ext uri="{9D8B030D-6E8A-4147-A177-3AD203B41FA5}">
+                      <a16:colId xmlns:a16="http://schemas.microsoft.com/office/drawing/2014/main" val="20003"/>
+                    </a:ext>
+                  </a:extLst>
+                </a:gridCol>
               </a:tblGrid>
               <a:tr h="411480">
                 <a:tc>
@@ -6537,6 +7060,11 @@
                     </a:solidFill>
                   </a:tcPr>
                 </a:tc>
+                <a:extLst>
+                  <a:ext uri="{0D108BD9-81ED-4DB2-BD59-A6C34878D82A}">
+                    <a16:rowId xmlns:a16="http://schemas.microsoft.com/office/drawing/2014/main" val="10000"/>
+                  </a:ext>
+                </a:extLst>
               </a:tr>
               <a:tr h="411480">
                 <a:tc>
@@ -6545,7 +7073,7 @@
                     <a:lstStyle/>
                     <a:p>
                       <a:pPr>
-                        <a:defRPr sz="1600">
+                        <a:defRPr sz="1600" b="0">
                           <a:solidFill>
                             <a:srgbClr val="F5F0E6"/>
                           </a:solidFill>
@@ -6569,7 +7097,7 @@
                     <a:lstStyle/>
                     <a:p>
                       <a:pPr>
-                        <a:defRPr sz="1600">
+                        <a:defRPr sz="1600" b="0">
                           <a:solidFill>
                             <a:srgbClr val="F5F0E6"/>
                           </a:solidFill>
@@ -6593,7 +7121,7 @@
                     <a:lstStyle/>
                     <a:p>
                       <a:pPr>
-                        <a:defRPr sz="1600">
+                        <a:defRPr sz="1600" b="0">
                           <a:solidFill>
                             <a:srgbClr val="F5F0E6"/>
                           </a:solidFill>
@@ -6617,7 +7145,7 @@
                     <a:lstStyle/>
                     <a:p>
                       <a:pPr>
-                        <a:defRPr sz="1600">
+                        <a:defRPr sz="1600" b="0">
                           <a:solidFill>
                             <a:srgbClr val="F5F0E6"/>
                           </a:solidFill>
@@ -6635,6 +7163,11 @@
                     </a:solidFill>
                   </a:tcPr>
                 </a:tc>
+                <a:extLst>
+                  <a:ext uri="{0D108BD9-81ED-4DB2-BD59-A6C34878D82A}">
+                    <a16:rowId xmlns:a16="http://schemas.microsoft.com/office/drawing/2014/main" val="10001"/>
+                  </a:ext>
+                </a:extLst>
               </a:tr>
               <a:tr h="411480">
                 <a:tc>
@@ -6643,7 +7176,7 @@
                     <a:lstStyle/>
                     <a:p>
                       <a:pPr>
-                        <a:defRPr sz="1600">
+                        <a:defRPr sz="1600" b="0">
                           <a:solidFill>
                             <a:srgbClr val="F5F0E6"/>
                           </a:solidFill>
@@ -6667,7 +7200,7 @@
                     <a:lstStyle/>
                     <a:p>
                       <a:pPr>
-                        <a:defRPr sz="1600">
+                        <a:defRPr sz="1600" b="0">
                           <a:solidFill>
                             <a:srgbClr val="F5F0E6"/>
                           </a:solidFill>
@@ -6691,7 +7224,7 @@
                     <a:lstStyle/>
                     <a:p>
                       <a:pPr>
-                        <a:defRPr sz="1600">
+                        <a:defRPr sz="1600" b="0">
                           <a:solidFill>
                             <a:srgbClr val="F5F0E6"/>
                           </a:solidFill>
@@ -6715,7 +7248,7 @@
                     <a:lstStyle/>
                     <a:p>
                       <a:pPr>
-                        <a:defRPr sz="1600">
+                        <a:defRPr sz="1600" b="0">
                           <a:solidFill>
                             <a:srgbClr val="F5F0E6"/>
                           </a:solidFill>
@@ -6733,6 +7266,11 @@
                     </a:solidFill>
                   </a:tcPr>
                 </a:tc>
+                <a:extLst>
+                  <a:ext uri="{0D108BD9-81ED-4DB2-BD59-A6C34878D82A}">
+                    <a16:rowId xmlns:a16="http://schemas.microsoft.com/office/drawing/2014/main" val="10002"/>
+                  </a:ext>
+                </a:extLst>
               </a:tr>
               <a:tr h="411480">
                 <a:tc>
@@ -6741,7 +7279,7 @@
                     <a:lstStyle/>
                     <a:p>
                       <a:pPr>
-                        <a:defRPr sz="1600">
+                        <a:defRPr sz="1600" b="0">
                           <a:solidFill>
                             <a:srgbClr val="F5F0E6"/>
                           </a:solidFill>
@@ -6765,7 +7303,7 @@
                     <a:lstStyle/>
                     <a:p>
                       <a:pPr>
-                        <a:defRPr sz="1600">
+                        <a:defRPr sz="1600" b="0">
                           <a:solidFill>
                             <a:srgbClr val="F5F0E6"/>
                           </a:solidFill>
@@ -6789,7 +7327,7 @@
                     <a:lstStyle/>
                     <a:p>
                       <a:pPr>
-                        <a:defRPr sz="1600">
+                        <a:defRPr sz="1600" b="0">
                           <a:solidFill>
                             <a:srgbClr val="F5F0E6"/>
                           </a:solidFill>
@@ -6813,7 +7351,7 @@
                     <a:lstStyle/>
                     <a:p>
                       <a:pPr>
-                        <a:defRPr sz="1600">
+                        <a:defRPr sz="1600" b="0">
                           <a:solidFill>
                             <a:srgbClr val="F5F0E6"/>
                           </a:solidFill>
@@ -6831,6 +7369,11 @@
                     </a:solidFill>
                   </a:tcPr>
                 </a:tc>
+                <a:extLst>
+                  <a:ext uri="{0D108BD9-81ED-4DB2-BD59-A6C34878D82A}">
+                    <a16:rowId xmlns:a16="http://schemas.microsoft.com/office/drawing/2014/main" val="10003"/>
+                  </a:ext>
+                </a:extLst>
               </a:tr>
               <a:tr h="411480">
                 <a:tc>
@@ -6839,7 +7382,7 @@
                     <a:lstStyle/>
                     <a:p>
                       <a:pPr>
-                        <a:defRPr sz="1600">
+                        <a:defRPr sz="1600" b="0">
                           <a:solidFill>
                             <a:srgbClr val="F5F0E6"/>
                           </a:solidFill>
@@ -6863,7 +7406,7 @@
                     <a:lstStyle/>
                     <a:p>
                       <a:pPr>
-                        <a:defRPr sz="1600">
+                        <a:defRPr sz="1600" b="0">
                           <a:solidFill>
                             <a:srgbClr val="F5F0E6"/>
                           </a:solidFill>
@@ -6887,7 +7430,7 @@
                     <a:lstStyle/>
                     <a:p>
                       <a:pPr>
-                        <a:defRPr sz="1600">
+                        <a:defRPr sz="1600" b="0">
                           <a:solidFill>
                             <a:srgbClr val="F5F0E6"/>
                           </a:solidFill>
@@ -6911,7 +7454,7 @@
                     <a:lstStyle/>
                     <a:p>
                       <a:pPr>
-                        <a:defRPr sz="1600">
+                        <a:defRPr sz="1600" b="0">
                           <a:solidFill>
                             <a:srgbClr val="F5F0E6"/>
                           </a:solidFill>
@@ -6929,6 +7472,11 @@
                     </a:solidFill>
                   </a:tcPr>
                 </a:tc>
+                <a:extLst>
+                  <a:ext uri="{0D108BD9-81ED-4DB2-BD59-A6C34878D82A}">
+                    <a16:rowId xmlns:a16="http://schemas.microsoft.com/office/drawing/2014/main" val="10004"/>
+                  </a:ext>
+                </a:extLst>
               </a:tr>
               <a:tr h="411480">
                 <a:tc>
@@ -6937,7 +7485,7 @@
                     <a:lstStyle/>
                     <a:p>
                       <a:pPr>
-                        <a:defRPr sz="1600">
+                        <a:defRPr sz="1600" b="0">
                           <a:solidFill>
                             <a:srgbClr val="F5F0E6"/>
                           </a:solidFill>
@@ -6961,7 +7509,7 @@
                     <a:lstStyle/>
                     <a:p>
                       <a:pPr>
-                        <a:defRPr sz="1600">
+                        <a:defRPr sz="1600" b="0">
                           <a:solidFill>
                             <a:srgbClr val="F5F0E6"/>
                           </a:solidFill>
@@ -6985,7 +7533,7 @@
                     <a:lstStyle/>
                     <a:p>
                       <a:pPr>
-                        <a:defRPr sz="1600">
+                        <a:defRPr sz="1600" b="0">
                           <a:solidFill>
                             <a:srgbClr val="F5F0E6"/>
                           </a:solidFill>
@@ -7009,7 +7557,7 @@
                     <a:lstStyle/>
                     <a:p>
                       <a:pPr>
-                        <a:defRPr sz="1600">
+                        <a:defRPr sz="1600" b="0">
                           <a:solidFill>
                             <a:srgbClr val="F5F0E6"/>
                           </a:solidFill>
@@ -7027,6 +7575,11 @@
                     </a:solidFill>
                   </a:tcPr>
                 </a:tc>
+                <a:extLst>
+                  <a:ext uri="{0D108BD9-81ED-4DB2-BD59-A6C34878D82A}">
+                    <a16:rowId xmlns:a16="http://schemas.microsoft.com/office/drawing/2014/main" val="10005"/>
+                  </a:ext>
+                </a:extLst>
               </a:tr>
             </a:tbl>
           </a:graphicData>
@@ -7081,7 +7634,7 @@
 </file>
 
 <file path=ppt/slides/slide6.xml><?xml version="1.0" encoding="utf-8"?>
-<p:sld xmlns:a="http://schemas.openxmlformats.org/drawingml/2006/main" xmlns:p="http://schemas.openxmlformats.org/presentationml/2006/main" xmlns:r="http://schemas.openxmlformats.org/officeDocument/2006/relationships">
+<p:sld xmlns:a="http://schemas.openxmlformats.org/drawingml/2006/main" xmlns:r="http://schemas.openxmlformats.org/officeDocument/2006/relationships" xmlns:p="http://schemas.openxmlformats.org/presentationml/2006/main">
   <p:cSld>
     <p:bg>
       <p:bgPr>
@@ -7097,7 +7650,14 @@
         <p:cNvGrpSpPr/>
         <p:nvPr/>
       </p:nvGrpSpPr>
-      <p:grpSpPr/>
+      <p:grpSpPr>
+        <a:xfrm>
+          <a:off x="0" y="0"/>
+          <a:ext cx="0" cy="0"/>
+          <a:chOff x="0" y="0"/>
+          <a:chExt cx="0" cy="0"/>
+        </a:xfrm>
+      </p:grpSpPr>
       <p:sp>
         <p:nvSpPr>
           <p:cNvPr id="2" name="TextBox 1"/>
@@ -7174,6 +7734,7 @@
           <a:lstStyle/>
           <a:p>
             <a:pPr algn="ctr"/>
+            <a:endParaRPr/>
           </a:p>
         </p:txBody>
       </p:sp>
@@ -7232,8 +7793,20 @@
                 <a:tableStyleId>{5C22544A-7EE6-4342-B048-85BDC9FD1C3A}</a:tableStyleId>
               </a:tblPr>
               <a:tblGrid>
-                <a:gridCol w="3200400"/>
-                <a:gridCol w="3200400"/>
+                <a:gridCol w="3840480">
+                  <a:extLst>
+                    <a:ext uri="{9D8B030D-6E8A-4147-A177-3AD203B41FA5}">
+                      <a16:colId xmlns:a16="http://schemas.microsoft.com/office/drawing/2014/main" val="20000"/>
+                    </a:ext>
+                  </a:extLst>
+                </a:gridCol>
+                <a:gridCol w="2560320">
+                  <a:extLst>
+                    <a:ext uri="{9D8B030D-6E8A-4147-A177-3AD203B41FA5}">
+                      <a16:colId xmlns:a16="http://schemas.microsoft.com/office/drawing/2014/main" val="20001"/>
+                    </a:ext>
+                  </a:extLst>
+                </a:gridCol>
               </a:tblGrid>
               <a:tr h="411480">
                 <a:tc>
@@ -7284,6 +7857,11 @@
                     </a:solidFill>
                   </a:tcPr>
                 </a:tc>
+                <a:extLst>
+                  <a:ext uri="{0D108BD9-81ED-4DB2-BD59-A6C34878D82A}">
+                    <a16:rowId xmlns:a16="http://schemas.microsoft.com/office/drawing/2014/main" val="10000"/>
+                  </a:ext>
+                </a:extLst>
               </a:tr>
               <a:tr h="411480">
                 <a:tc>
@@ -7292,7 +7870,7 @@
                     <a:lstStyle/>
                     <a:p>
                       <a:pPr>
-                        <a:defRPr sz="1500">
+                        <a:defRPr sz="1500" b="0">
                           <a:solidFill>
                             <a:srgbClr val="F5F0E6"/>
                           </a:solidFill>
@@ -7316,7 +7894,7 @@
                     <a:lstStyle/>
                     <a:p>
                       <a:pPr>
-                        <a:defRPr sz="1500">
+                        <a:defRPr sz="1500" b="0">
                           <a:solidFill>
                             <a:srgbClr val="F5F0E6"/>
                           </a:solidFill>
@@ -7334,6 +7912,11 @@
                     </a:solidFill>
                   </a:tcPr>
                 </a:tc>
+                <a:extLst>
+                  <a:ext uri="{0D108BD9-81ED-4DB2-BD59-A6C34878D82A}">
+                    <a16:rowId xmlns:a16="http://schemas.microsoft.com/office/drawing/2014/main" val="10001"/>
+                  </a:ext>
+                </a:extLst>
               </a:tr>
               <a:tr h="411480">
                 <a:tc>
@@ -7342,7 +7925,7 @@
                     <a:lstStyle/>
                     <a:p>
                       <a:pPr>
-                        <a:defRPr sz="1500">
+                        <a:defRPr sz="1500" b="0">
                           <a:solidFill>
                             <a:srgbClr val="F5F0E6"/>
                           </a:solidFill>
@@ -7366,7 +7949,7 @@
                     <a:lstStyle/>
                     <a:p>
                       <a:pPr>
-                        <a:defRPr sz="1500">
+                        <a:defRPr sz="1500" b="0">
                           <a:solidFill>
                             <a:srgbClr val="F5F0E6"/>
                           </a:solidFill>
@@ -7384,6 +7967,11 @@
                     </a:solidFill>
                   </a:tcPr>
                 </a:tc>
+                <a:extLst>
+                  <a:ext uri="{0D108BD9-81ED-4DB2-BD59-A6C34878D82A}">
+                    <a16:rowId xmlns:a16="http://schemas.microsoft.com/office/drawing/2014/main" val="10002"/>
+                  </a:ext>
+                </a:extLst>
               </a:tr>
               <a:tr h="411480">
                 <a:tc>
@@ -7392,7 +7980,7 @@
                     <a:lstStyle/>
                     <a:p>
                       <a:pPr>
-                        <a:defRPr sz="1500">
+                        <a:defRPr sz="1500" b="0">
                           <a:solidFill>
                             <a:srgbClr val="F5F0E6"/>
                           </a:solidFill>
@@ -7416,7 +8004,7 @@
                     <a:lstStyle/>
                     <a:p>
                       <a:pPr>
-                        <a:defRPr sz="1500">
+                        <a:defRPr sz="1500" b="0">
                           <a:solidFill>
                             <a:srgbClr val="F5F0E6"/>
                           </a:solidFill>
@@ -7434,6 +8022,11 @@
                     </a:solidFill>
                   </a:tcPr>
                 </a:tc>
+                <a:extLst>
+                  <a:ext uri="{0D108BD9-81ED-4DB2-BD59-A6C34878D82A}">
+                    <a16:rowId xmlns:a16="http://schemas.microsoft.com/office/drawing/2014/main" val="10003"/>
+                  </a:ext>
+                </a:extLst>
               </a:tr>
               <a:tr h="411480">
                 <a:tc>
@@ -7442,7 +8035,7 @@
                     <a:lstStyle/>
                     <a:p>
                       <a:pPr>
-                        <a:defRPr sz="1500">
+                        <a:defRPr sz="1500" b="0">
                           <a:solidFill>
                             <a:srgbClr val="F5F0E6"/>
                           </a:solidFill>
@@ -7466,7 +8059,7 @@
                     <a:lstStyle/>
                     <a:p>
                       <a:pPr>
-                        <a:defRPr sz="1500">
+                        <a:defRPr sz="1500" b="0">
                           <a:solidFill>
                             <a:srgbClr val="F5F0E6"/>
                           </a:solidFill>
@@ -7484,6 +8077,11 @@
                     </a:solidFill>
                   </a:tcPr>
                 </a:tc>
+                <a:extLst>
+                  <a:ext uri="{0D108BD9-81ED-4DB2-BD59-A6C34878D82A}">
+                    <a16:rowId xmlns:a16="http://schemas.microsoft.com/office/drawing/2014/main" val="10004"/>
+                  </a:ext>
+                </a:extLst>
               </a:tr>
               <a:tr h="411480">
                 <a:tc>
@@ -7492,7 +8090,7 @@
                     <a:lstStyle/>
                     <a:p>
                       <a:pPr>
-                        <a:defRPr sz="1500">
+                        <a:defRPr sz="1500" b="0">
                           <a:solidFill>
                             <a:srgbClr val="F5F0E6"/>
                           </a:solidFill>
@@ -7516,7 +8114,7 @@
                     <a:lstStyle/>
                     <a:p>
                       <a:pPr>
-                        <a:defRPr sz="1500">
+                        <a:defRPr sz="1500" b="0">
                           <a:solidFill>
                             <a:srgbClr val="F5F0E6"/>
                           </a:solidFill>
@@ -7534,6 +8132,11 @@
                     </a:solidFill>
                   </a:tcPr>
                 </a:tc>
+                <a:extLst>
+                  <a:ext uri="{0D108BD9-81ED-4DB2-BD59-A6C34878D82A}">
+                    <a16:rowId xmlns:a16="http://schemas.microsoft.com/office/drawing/2014/main" val="10005"/>
+                  </a:ext>
+                </a:extLst>
               </a:tr>
               <a:tr h="411480">
                 <a:tc>
@@ -7542,7 +8145,7 @@
                     <a:lstStyle/>
                     <a:p>
                       <a:pPr>
-                        <a:defRPr sz="1500">
+                        <a:defRPr sz="1500" b="0">
                           <a:solidFill>
                             <a:srgbClr val="F5F0E6"/>
                           </a:solidFill>
@@ -7566,7 +8169,7 @@
                     <a:lstStyle/>
                     <a:p>
                       <a:pPr>
-                        <a:defRPr sz="1500">
+                        <a:defRPr sz="1500" b="0">
                           <a:solidFill>
                             <a:srgbClr val="F5F0E6"/>
                           </a:solidFill>
@@ -7584,6 +8187,11 @@
                     </a:solidFill>
                   </a:tcPr>
                 </a:tc>
+                <a:extLst>
+                  <a:ext uri="{0D108BD9-81ED-4DB2-BD59-A6C34878D82A}">
+                    <a16:rowId xmlns:a16="http://schemas.microsoft.com/office/drawing/2014/main" val="10006"/>
+                  </a:ext>
+                </a:extLst>
               </a:tr>
               <a:tr h="411480">
                 <a:tc>
@@ -7592,7 +8200,7 @@
                     <a:lstStyle/>
                     <a:p>
                       <a:pPr>
-                        <a:defRPr sz="1500">
+                        <a:defRPr sz="1500" b="0">
                           <a:solidFill>
                             <a:srgbClr val="F5F0E6"/>
                           </a:solidFill>
@@ -7616,7 +8224,7 @@
                     <a:lstStyle/>
                     <a:p>
                       <a:pPr>
-                        <a:defRPr sz="1500">
+                        <a:defRPr sz="1500" b="0">
                           <a:solidFill>
                             <a:srgbClr val="F5F0E6"/>
                           </a:solidFill>
@@ -7634,6 +8242,11 @@
                     </a:solidFill>
                   </a:tcPr>
                 </a:tc>
+                <a:extLst>
+                  <a:ext uri="{0D108BD9-81ED-4DB2-BD59-A6C34878D82A}">
+                    <a16:rowId xmlns:a16="http://schemas.microsoft.com/office/drawing/2014/main" val="10007"/>
+                  </a:ext>
+                </a:extLst>
               </a:tr>
             </a:tbl>
           </a:graphicData>
@@ -7679,6 +8292,7 @@
           <a:lstStyle/>
           <a:p>
             <a:pPr algn="ctr"/>
+            <a:endParaRPr/>
           </a:p>
         </p:txBody>
       </p:sp>
@@ -7747,6 +8361,7 @@
                 <a:latin typeface="Georgia"/>
               </a:defRPr>
             </a:pPr>
+            <a:endParaRPr/>
           </a:p>
           <a:p>
             <a:pPr>
@@ -7792,6 +8407,7 @@
                 <a:latin typeface="Georgia"/>
               </a:defRPr>
             </a:pPr>
+            <a:endParaRPr/>
           </a:p>
           <a:p>
             <a:pPr>
@@ -7852,7 +8468,7 @@
 </file>
 
 <file path=ppt/slides/slide7.xml><?xml version="1.0" encoding="utf-8"?>
-<p:sld xmlns:a="http://schemas.openxmlformats.org/drawingml/2006/main" xmlns:p="http://schemas.openxmlformats.org/presentationml/2006/main" xmlns:r="http://schemas.openxmlformats.org/officeDocument/2006/relationships">
+<p:sld xmlns:a="http://schemas.openxmlformats.org/drawingml/2006/main" xmlns:r="http://schemas.openxmlformats.org/officeDocument/2006/relationships" xmlns:p="http://schemas.openxmlformats.org/presentationml/2006/main">
   <p:cSld>
     <p:bg>
       <p:bgPr>
@@ -7868,7 +8484,14 @@
         <p:cNvGrpSpPr/>
         <p:nvPr/>
       </p:nvGrpSpPr>
-      <p:grpSpPr/>
+      <p:grpSpPr>
+        <a:xfrm>
+          <a:off x="0" y="0"/>
+          <a:ext cx="0" cy="0"/>
+          <a:chOff x="0" y="0"/>
+          <a:chExt cx="0" cy="0"/>
+        </a:xfrm>
+      </p:grpSpPr>
       <p:sp>
         <p:nvSpPr>
           <p:cNvPr id="2" name="TextBox 1"/>
@@ -7945,6 +8568,7 @@
           <a:lstStyle/>
           <a:p>
             <a:pPr algn="ctr"/>
+            <a:endParaRPr/>
           </a:p>
         </p:txBody>
       </p:sp>
@@ -7967,10 +8591,34 @@
                 <a:tableStyleId>{5C22544A-7EE6-4342-B048-85BDC9FD1C3A}</a:tableStyleId>
               </a:tblPr>
               <a:tblGrid>
-                <a:gridCol w="2674620"/>
-                <a:gridCol w="2674620"/>
-                <a:gridCol w="2674620"/>
-                <a:gridCol w="2674620"/>
+                <a:gridCol w="2286000">
+                  <a:extLst>
+                    <a:ext uri="{9D8B030D-6E8A-4147-A177-3AD203B41FA5}">
+                      <a16:colId xmlns:a16="http://schemas.microsoft.com/office/drawing/2014/main" val="20000"/>
+                    </a:ext>
+                  </a:extLst>
+                </a:gridCol>
+                <a:gridCol w="2743200">
+                  <a:extLst>
+                    <a:ext uri="{9D8B030D-6E8A-4147-A177-3AD203B41FA5}">
+                      <a16:colId xmlns:a16="http://schemas.microsoft.com/office/drawing/2014/main" val="20001"/>
+                    </a:ext>
+                  </a:extLst>
+                </a:gridCol>
+                <a:gridCol w="2743200">
+                  <a:extLst>
+                    <a:ext uri="{9D8B030D-6E8A-4147-A177-3AD203B41FA5}">
+                      <a16:colId xmlns:a16="http://schemas.microsoft.com/office/drawing/2014/main" val="20002"/>
+                    </a:ext>
+                  </a:extLst>
+                </a:gridCol>
+                <a:gridCol w="2926080">
+                  <a:extLst>
+                    <a:ext uri="{9D8B030D-6E8A-4147-A177-3AD203B41FA5}">
+                      <a16:colId xmlns:a16="http://schemas.microsoft.com/office/drawing/2014/main" val="20003"/>
+                    </a:ext>
+                  </a:extLst>
+                </a:gridCol>
               </a:tblGrid>
               <a:tr h="411480">
                 <a:tc>
@@ -8069,6 +8717,11 @@
                     </a:solidFill>
                   </a:tcPr>
                 </a:tc>
+                <a:extLst>
+                  <a:ext uri="{0D108BD9-81ED-4DB2-BD59-A6C34878D82A}">
+                    <a16:rowId xmlns:a16="http://schemas.microsoft.com/office/drawing/2014/main" val="10000"/>
+                  </a:ext>
+                </a:extLst>
               </a:tr>
               <a:tr h="411480">
                 <a:tc>
@@ -8077,7 +8730,7 @@
                     <a:lstStyle/>
                     <a:p>
                       <a:pPr>
-                        <a:defRPr sz="1800">
+                        <a:defRPr sz="1800" b="0">
                           <a:solidFill>
                             <a:srgbClr val="F5F0E6"/>
                           </a:solidFill>
@@ -8101,7 +8754,7 @@
                     <a:lstStyle/>
                     <a:p>
                       <a:pPr>
-                        <a:defRPr sz="1800">
+                        <a:defRPr sz="1800" b="0">
                           <a:solidFill>
                             <a:srgbClr val="F5F0E6"/>
                           </a:solidFill>
@@ -8125,7 +8778,7 @@
                     <a:lstStyle/>
                     <a:p>
                       <a:pPr>
-                        <a:defRPr sz="1800">
+                        <a:defRPr sz="1800" b="0">
                           <a:solidFill>
                             <a:srgbClr val="F5F0E6"/>
                           </a:solidFill>
@@ -8149,7 +8802,7 @@
                     <a:lstStyle/>
                     <a:p>
                       <a:pPr>
-                        <a:defRPr sz="1800">
+                        <a:defRPr sz="1800" b="0">
                           <a:solidFill>
                             <a:srgbClr val="F5F0E6"/>
                           </a:solidFill>
@@ -8167,6 +8820,11 @@
                     </a:solidFill>
                   </a:tcPr>
                 </a:tc>
+                <a:extLst>
+                  <a:ext uri="{0D108BD9-81ED-4DB2-BD59-A6C34878D82A}">
+                    <a16:rowId xmlns:a16="http://schemas.microsoft.com/office/drawing/2014/main" val="10001"/>
+                  </a:ext>
+                </a:extLst>
               </a:tr>
               <a:tr h="411480">
                 <a:tc>
@@ -8175,7 +8833,7 @@
                     <a:lstStyle/>
                     <a:p>
                       <a:pPr>
-                        <a:defRPr sz="1800">
+                        <a:defRPr sz="1800" b="0">
                           <a:solidFill>
                             <a:srgbClr val="F5F0E6"/>
                           </a:solidFill>
@@ -8199,7 +8857,7 @@
                     <a:lstStyle/>
                     <a:p>
                       <a:pPr>
-                        <a:defRPr sz="1800">
+                        <a:defRPr sz="1800" b="0">
                           <a:solidFill>
                             <a:srgbClr val="F5F0E6"/>
                           </a:solidFill>
@@ -8223,7 +8881,7 @@
                     <a:lstStyle/>
                     <a:p>
                       <a:pPr>
-                        <a:defRPr sz="1800">
+                        <a:defRPr sz="1800" b="0">
                           <a:solidFill>
                             <a:srgbClr val="F5F0E6"/>
                           </a:solidFill>
@@ -8247,7 +8905,7 @@
                     <a:lstStyle/>
                     <a:p>
                       <a:pPr>
-                        <a:defRPr sz="1800">
+                        <a:defRPr sz="1800" b="0">
                           <a:solidFill>
                             <a:srgbClr val="F5F0E6"/>
                           </a:solidFill>
@@ -8265,6 +8923,11 @@
                     </a:solidFill>
                   </a:tcPr>
                 </a:tc>
+                <a:extLst>
+                  <a:ext uri="{0D108BD9-81ED-4DB2-BD59-A6C34878D82A}">
+                    <a16:rowId xmlns:a16="http://schemas.microsoft.com/office/drawing/2014/main" val="10002"/>
+                  </a:ext>
+                </a:extLst>
               </a:tr>
               <a:tr h="411480">
                 <a:tc>
@@ -8273,7 +8936,7 @@
                     <a:lstStyle/>
                     <a:p>
                       <a:pPr>
-                        <a:defRPr sz="1800">
+                        <a:defRPr sz="1800" b="0">
                           <a:solidFill>
                             <a:srgbClr val="F5F0E6"/>
                           </a:solidFill>
@@ -8297,7 +8960,7 @@
                     <a:lstStyle/>
                     <a:p>
                       <a:pPr>
-                        <a:defRPr sz="1800">
+                        <a:defRPr sz="1800" b="0">
                           <a:solidFill>
                             <a:srgbClr val="F5F0E6"/>
                           </a:solidFill>
@@ -8321,7 +8984,7 @@
                     <a:lstStyle/>
                     <a:p>
                       <a:pPr>
-                        <a:defRPr sz="1800">
+                        <a:defRPr sz="1800" b="0">
                           <a:solidFill>
                             <a:srgbClr val="F5F0E6"/>
                           </a:solidFill>
@@ -8345,7 +9008,7 @@
                     <a:lstStyle/>
                     <a:p>
                       <a:pPr>
-                        <a:defRPr sz="1800">
+                        <a:defRPr sz="1800" b="0">
                           <a:solidFill>
                             <a:srgbClr val="F5F0E6"/>
                           </a:solidFill>
@@ -8363,6 +9026,11 @@
                     </a:solidFill>
                   </a:tcPr>
                 </a:tc>
+                <a:extLst>
+                  <a:ext uri="{0D108BD9-81ED-4DB2-BD59-A6C34878D82A}">
+                    <a16:rowId xmlns:a16="http://schemas.microsoft.com/office/drawing/2014/main" val="10003"/>
+                  </a:ext>
+                </a:extLst>
               </a:tr>
             </a:tbl>
           </a:graphicData>
@@ -8433,6 +9101,7 @@
                 <a:latin typeface="Georgia"/>
               </a:defRPr>
             </a:pPr>
+            <a:endParaRPr/>
           </a:p>
           <a:p>
             <a:pPr>
@@ -8478,6 +9147,7 @@
                 <a:latin typeface="Georgia"/>
               </a:defRPr>
             </a:pPr>
+            <a:endParaRPr/>
           </a:p>
           <a:p>
             <a:pPr>
@@ -8506,7 +9176,7 @@
 </file>
 
 <file path=ppt/slides/slide8.xml><?xml version="1.0" encoding="utf-8"?>
-<p:sld xmlns:a="http://schemas.openxmlformats.org/drawingml/2006/main" xmlns:p="http://schemas.openxmlformats.org/presentationml/2006/main" xmlns:r="http://schemas.openxmlformats.org/officeDocument/2006/relationships">
+<p:sld xmlns:a="http://schemas.openxmlformats.org/drawingml/2006/main" xmlns:r="http://schemas.openxmlformats.org/officeDocument/2006/relationships" xmlns:p="http://schemas.openxmlformats.org/presentationml/2006/main">
   <p:cSld>
     <p:bg>
       <p:bgPr>
@@ -8522,7 +9192,14 @@
         <p:cNvGrpSpPr/>
         <p:nvPr/>
       </p:nvGrpSpPr>
-      <p:grpSpPr/>
+      <p:grpSpPr>
+        <a:xfrm>
+          <a:off x="0" y="0"/>
+          <a:ext cx="0" cy="0"/>
+          <a:chOff x="0" y="0"/>
+          <a:chExt cx="0" cy="0"/>
+        </a:xfrm>
+      </p:grpSpPr>
       <p:sp>
         <p:nvSpPr>
           <p:cNvPr id="2" name="TextBox 1"/>
@@ -8599,6 +9276,7 @@
           <a:lstStyle/>
           <a:p>
             <a:pPr algn="ctr"/>
+            <a:endParaRPr/>
           </a:p>
         </p:txBody>
       </p:sp>
@@ -8657,10 +9335,34 @@
                 <a:tableStyleId>{5C22544A-7EE6-4342-B048-85BDC9FD1C3A}</a:tableStyleId>
               </a:tblPr>
               <a:tblGrid>
-                <a:gridCol w="2674620"/>
-                <a:gridCol w="2674620"/>
-                <a:gridCol w="2674620"/>
-                <a:gridCol w="2674620"/>
+                <a:gridCol w="2011680">
+                  <a:extLst>
+                    <a:ext uri="{9D8B030D-6E8A-4147-A177-3AD203B41FA5}">
+                      <a16:colId xmlns:a16="http://schemas.microsoft.com/office/drawing/2014/main" val="20000"/>
+                    </a:ext>
+                  </a:extLst>
+                </a:gridCol>
+                <a:gridCol w="4572000">
+                  <a:extLst>
+                    <a:ext uri="{9D8B030D-6E8A-4147-A177-3AD203B41FA5}">
+                      <a16:colId xmlns:a16="http://schemas.microsoft.com/office/drawing/2014/main" val="20001"/>
+                    </a:ext>
+                  </a:extLst>
+                </a:gridCol>
+                <a:gridCol w="1828800">
+                  <a:extLst>
+                    <a:ext uri="{9D8B030D-6E8A-4147-A177-3AD203B41FA5}">
+                      <a16:colId xmlns:a16="http://schemas.microsoft.com/office/drawing/2014/main" val="20002"/>
+                    </a:ext>
+                  </a:extLst>
+                </a:gridCol>
+                <a:gridCol w="2286000">
+                  <a:extLst>
+                    <a:ext uri="{9D8B030D-6E8A-4147-A177-3AD203B41FA5}">
+                      <a16:colId xmlns:a16="http://schemas.microsoft.com/office/drawing/2014/main" val="20003"/>
+                    </a:ext>
+                  </a:extLst>
+                </a:gridCol>
               </a:tblGrid>
               <a:tr h="411480">
                 <a:tc>
@@ -8759,6 +9461,11 @@
                     </a:solidFill>
                   </a:tcPr>
                 </a:tc>
+                <a:extLst>
+                  <a:ext uri="{0D108BD9-81ED-4DB2-BD59-A6C34878D82A}">
+                    <a16:rowId xmlns:a16="http://schemas.microsoft.com/office/drawing/2014/main" val="10000"/>
+                  </a:ext>
+                </a:extLst>
               </a:tr>
               <a:tr h="411480">
                 <a:tc>
@@ -8767,7 +9474,7 @@
                     <a:lstStyle/>
                     <a:p>
                       <a:pPr>
-                        <a:defRPr sz="1500">
+                        <a:defRPr sz="1500" b="0">
                           <a:solidFill>
                             <a:srgbClr val="F5F0E6"/>
                           </a:solidFill>
@@ -8791,7 +9498,7 @@
                     <a:lstStyle/>
                     <a:p>
                       <a:pPr>
-                        <a:defRPr sz="1500">
+                        <a:defRPr sz="1500" b="0">
                           <a:solidFill>
                             <a:srgbClr val="F5F0E6"/>
                           </a:solidFill>
@@ -8815,7 +9522,7 @@
                     <a:lstStyle/>
                     <a:p>
                       <a:pPr>
-                        <a:defRPr sz="1500">
+                        <a:defRPr sz="1500" b="0">
                           <a:solidFill>
                             <a:srgbClr val="F5F0E6"/>
                           </a:solidFill>
@@ -8839,7 +9546,7 @@
                     <a:lstStyle/>
                     <a:p>
                       <a:pPr>
-                        <a:defRPr sz="1500">
+                        <a:defRPr sz="1500" b="0">
                           <a:solidFill>
                             <a:srgbClr val="F5F0E6"/>
                           </a:solidFill>
@@ -8857,6 +9564,11 @@
                     </a:solidFill>
                   </a:tcPr>
                 </a:tc>
+                <a:extLst>
+                  <a:ext uri="{0D108BD9-81ED-4DB2-BD59-A6C34878D82A}">
+                    <a16:rowId xmlns:a16="http://schemas.microsoft.com/office/drawing/2014/main" val="10001"/>
+                  </a:ext>
+                </a:extLst>
               </a:tr>
               <a:tr h="411480">
                 <a:tc>
@@ -8865,7 +9577,7 @@
                     <a:lstStyle/>
                     <a:p>
                       <a:pPr>
-                        <a:defRPr sz="1500">
+                        <a:defRPr sz="1500" b="0">
                           <a:solidFill>
                             <a:srgbClr val="F5F0E6"/>
                           </a:solidFill>
@@ -8889,7 +9601,7 @@
                     <a:lstStyle/>
                     <a:p>
                       <a:pPr>
-                        <a:defRPr sz="1500">
+                        <a:defRPr sz="1500" b="0">
                           <a:solidFill>
                             <a:srgbClr val="F5F0E6"/>
                           </a:solidFill>
@@ -8913,7 +9625,7 @@
                     <a:lstStyle/>
                     <a:p>
                       <a:pPr>
-                        <a:defRPr sz="1500">
+                        <a:defRPr sz="1500" b="0">
                           <a:solidFill>
                             <a:srgbClr val="F5F0E6"/>
                           </a:solidFill>
@@ -8937,7 +9649,7 @@
                     <a:lstStyle/>
                     <a:p>
                       <a:pPr>
-                        <a:defRPr sz="1500">
+                        <a:defRPr sz="1500" b="0">
                           <a:solidFill>
                             <a:srgbClr val="F5F0E6"/>
                           </a:solidFill>
@@ -8955,6 +9667,11 @@
                     </a:solidFill>
                   </a:tcPr>
                 </a:tc>
+                <a:extLst>
+                  <a:ext uri="{0D108BD9-81ED-4DB2-BD59-A6C34878D82A}">
+                    <a16:rowId xmlns:a16="http://schemas.microsoft.com/office/drawing/2014/main" val="10002"/>
+                  </a:ext>
+                </a:extLst>
               </a:tr>
               <a:tr h="411480">
                 <a:tc>
@@ -8963,7 +9680,7 @@
                     <a:lstStyle/>
                     <a:p>
                       <a:pPr>
-                        <a:defRPr sz="1500">
+                        <a:defRPr sz="1500" b="0">
                           <a:solidFill>
                             <a:srgbClr val="F5F0E6"/>
                           </a:solidFill>
@@ -8987,7 +9704,7 @@
                     <a:lstStyle/>
                     <a:p>
                       <a:pPr>
-                        <a:defRPr sz="1500">
+                        <a:defRPr sz="1500" b="0">
                           <a:solidFill>
                             <a:srgbClr val="F5F0E6"/>
                           </a:solidFill>
@@ -9011,7 +9728,7 @@
                     <a:lstStyle/>
                     <a:p>
                       <a:pPr>
-                        <a:defRPr sz="1500">
+                        <a:defRPr sz="1500" b="0">
                           <a:solidFill>
                             <a:srgbClr val="F5F0E6"/>
                           </a:solidFill>
@@ -9035,7 +9752,7 @@
                     <a:lstStyle/>
                     <a:p>
                       <a:pPr>
-                        <a:defRPr sz="1500">
+                        <a:defRPr sz="1500" b="0">
                           <a:solidFill>
                             <a:srgbClr val="F5F0E6"/>
                           </a:solidFill>
@@ -9053,6 +9770,11 @@
                     </a:solidFill>
                   </a:tcPr>
                 </a:tc>
+                <a:extLst>
+                  <a:ext uri="{0D108BD9-81ED-4DB2-BD59-A6C34878D82A}">
+                    <a16:rowId xmlns:a16="http://schemas.microsoft.com/office/drawing/2014/main" val="10003"/>
+                  </a:ext>
+                </a:extLst>
               </a:tr>
               <a:tr h="411480">
                 <a:tc>
@@ -9061,7 +9783,7 @@
                     <a:lstStyle/>
                     <a:p>
                       <a:pPr>
-                        <a:defRPr sz="1500">
+                        <a:defRPr sz="1500" b="0">
                           <a:solidFill>
                             <a:srgbClr val="F5F0E6"/>
                           </a:solidFill>
@@ -9085,7 +9807,7 @@
                     <a:lstStyle/>
                     <a:p>
                       <a:pPr>
-                        <a:defRPr sz="1500">
+                        <a:defRPr sz="1500" b="0">
                           <a:solidFill>
                             <a:srgbClr val="F5F0E6"/>
                           </a:solidFill>
@@ -9109,7 +9831,7 @@
                     <a:lstStyle/>
                     <a:p>
                       <a:pPr>
-                        <a:defRPr sz="1500">
+                        <a:defRPr sz="1500" b="0">
                           <a:solidFill>
                             <a:srgbClr val="F5F0E6"/>
                           </a:solidFill>
@@ -9133,7 +9855,7 @@
                     <a:lstStyle/>
                     <a:p>
                       <a:pPr>
-                        <a:defRPr sz="1500">
+                        <a:defRPr sz="1500" b="0">
                           <a:solidFill>
                             <a:srgbClr val="F5F0E6"/>
                           </a:solidFill>
@@ -9151,6 +9873,11 @@
                     </a:solidFill>
                   </a:tcPr>
                 </a:tc>
+                <a:extLst>
+                  <a:ext uri="{0D108BD9-81ED-4DB2-BD59-A6C34878D82A}">
+                    <a16:rowId xmlns:a16="http://schemas.microsoft.com/office/drawing/2014/main" val="10004"/>
+                  </a:ext>
+                </a:extLst>
               </a:tr>
             </a:tbl>
           </a:graphicData>
@@ -9236,7 +9963,7 @@
 </file>
 
 <file path=ppt/slides/slide9.xml><?xml version="1.0" encoding="utf-8"?>
-<p:sld xmlns:a="http://schemas.openxmlformats.org/drawingml/2006/main" xmlns:p="http://schemas.openxmlformats.org/presentationml/2006/main" xmlns:r="http://schemas.openxmlformats.org/officeDocument/2006/relationships">
+<p:sld xmlns:a="http://schemas.openxmlformats.org/drawingml/2006/main" xmlns:r="http://schemas.openxmlformats.org/officeDocument/2006/relationships" xmlns:p="http://schemas.openxmlformats.org/presentationml/2006/main">
   <p:cSld>
     <p:bg>
       <p:bgPr>
@@ -9252,7 +9979,14 @@
         <p:cNvGrpSpPr/>
         <p:nvPr/>
       </p:nvGrpSpPr>
-      <p:grpSpPr/>
+      <p:grpSpPr>
+        <a:xfrm>
+          <a:off x="0" y="0"/>
+          <a:ext cx="0" cy="0"/>
+          <a:chOff x="0" y="0"/>
+          <a:chExt cx="0" cy="0"/>
+        </a:xfrm>
+      </p:grpSpPr>
       <p:sp>
         <p:nvSpPr>
           <p:cNvPr id="2" name="TextBox 1"/>
@@ -9329,6 +10063,7 @@
           <a:lstStyle/>
           <a:p>
             <a:pPr algn="ctr"/>
+            <a:endParaRPr/>
           </a:p>
         </p:txBody>
       </p:sp>
@@ -9664,7 +10399,7 @@
         </p:nvSpPr>
         <p:spPr>
           <a:xfrm>
-            <a:off x="731520" y="3200400"/>
+            <a:off x="731520" y="3200399"/>
             <a:ext cx="457200" cy="457200"/>
           </a:xfrm>
           <a:prstGeom prst="rect">
@@ -9700,7 +10435,7 @@
         </p:nvSpPr>
         <p:spPr>
           <a:xfrm>
-            <a:off x="1280160" y="3200400"/>
+            <a:off x="1280160" y="3200399"/>
             <a:ext cx="4114800" cy="457200"/>
           </a:xfrm>
           <a:prstGeom prst="rect">
@@ -9736,7 +10471,7 @@
         </p:nvSpPr>
         <p:spPr>
           <a:xfrm>
-            <a:off x="5486400" y="3200400"/>
+            <a:off x="5486400" y="3200399"/>
             <a:ext cx="5943600" cy="457200"/>
           </a:xfrm>
           <a:prstGeom prst="rect">
@@ -9772,7 +10507,7 @@
         </p:nvSpPr>
         <p:spPr>
           <a:xfrm>
-            <a:off x="731520" y="3749039"/>
+            <a:off x="731520" y="3749040"/>
             <a:ext cx="457200" cy="457200"/>
           </a:xfrm>
           <a:prstGeom prst="rect">
@@ -9808,7 +10543,7 @@
         </p:nvSpPr>
         <p:spPr>
           <a:xfrm>
-            <a:off x="1280160" y="3749039"/>
+            <a:off x="1280160" y="3749040"/>
             <a:ext cx="4114800" cy="457200"/>
           </a:xfrm>
           <a:prstGeom prst="rect">
@@ -9844,7 +10579,7 @@
         </p:nvSpPr>
         <p:spPr>
           <a:xfrm>
-            <a:off x="5486400" y="3749039"/>
+            <a:off x="5486400" y="3749040"/>
             <a:ext cx="5943600" cy="457200"/>
           </a:xfrm>
           <a:prstGeom prst="rect">
@@ -9988,7 +10723,7 @@
         </p:nvSpPr>
         <p:spPr>
           <a:xfrm>
-            <a:off x="731520" y="4846320"/>
+            <a:off x="731520" y="4846319"/>
             <a:ext cx="457200" cy="457200"/>
           </a:xfrm>
           <a:prstGeom prst="rect">
@@ -10024,7 +10759,7 @@
         </p:nvSpPr>
         <p:spPr>
           <a:xfrm>
-            <a:off x="1280160" y="4846320"/>
+            <a:off x="1280160" y="4846319"/>
             <a:ext cx="4114800" cy="457200"/>
           </a:xfrm>
           <a:prstGeom prst="rect">
@@ -10060,7 +10795,7 @@
         </p:nvSpPr>
         <p:spPr>
           <a:xfrm>
-            <a:off x="5486400" y="4846320"/>
+            <a:off x="5486400" y="4846319"/>
             <a:ext cx="5943600" cy="457200"/>
           </a:xfrm>
           <a:prstGeom prst="rect">
@@ -10111,7 +10846,7 @@
           <a:lstStyle/>
           <a:p>
             <a:pPr algn="l">
-              <a:defRPr sz="1800" b="1">
+              <a:defRPr sz="2000" b="1">
                 <a:solidFill>
                   <a:srgbClr val="C8A25C"/>
                 </a:solidFill>

</xml_diff>